<commit_message>
successfull build complete integrate UI
</commit_message>
<xml_diff>
--- a/CardioTriage_ML_Phase.pptx
+++ b/CardioTriage_ML_Phase.pptx
@@ -22,9 +22,11 @@
     <p:sldId id="270" r:id="rId16"/>
     <p:sldId id="271" r:id="rId17"/>
     <p:sldId id="272" r:id="rId18"/>
+    <p:sldId id="273" r:id="rId19"/>
+    <p:sldId id="274" r:id="rId20"/>
   </p:sldIdLst>
   <p:notesMasterIdLst>
-    <p:notesMasterId r:id="rId19"/>
+    <p:notesMasterId r:id="rId21"/>
   </p:notesMasterIdLst>
   <p:sldSz cx="12192000" cy="6858000"/>
   <p:notesSz cx="6858000" cy="12192000"/>
@@ -1437,6 +1439,287 @@
 </c:chartSpace>
 </file>
 
+<file path=ppt/charts/chart6.xml><?xml version="1.0" encoding="utf-8"?>
+<c:chartSpace xmlns:c="http://schemas.openxmlformats.org/drawingml/2006/chart" xmlns:a="http://schemas.openxmlformats.org/drawingml/2006/main" xmlns:r="http://schemas.openxmlformats.org/officeDocument/2006/relationships">
+  <c:date1904 val="0"/>
+  <c:roundedCorners val="1"/>
+  <c:chart>
+    <c:autoTitleDeleted val="1"/>
+    <c:plotArea>
+      <c:layout/>
+      <c:barChart>
+        <c:barDir val="col"/>
+        <c:grouping val="clustered"/>
+        <c:varyColors val="0"/>
+        <c:ser>
+          <c:idx val="0"/>
+          <c:order val="0"/>
+          <c:tx>
+            <c:strRef>
+              <c:f>Sheet1!$B$1</c:f>
+              <c:strCache>
+                <c:ptCount val="1"/>
+                <c:pt idx="0">
+                  <c:v>CV AUC</c:v>
+                </c:pt>
+              </c:strCache>
+            </c:strRef>
+          </c:tx>
+          <c:spPr>
+            <a:solidFill>
+              <a:srgbClr val="1C7293"/>
+            </a:solidFill>
+            <a:effectLst/>
+          </c:spPr>
+          <c:invertIfNegative val="0"/>
+          <c:dLbls>
+            <c:numFmt formatCode="0.000" sourceLinked="0"/>
+            <c:txPr>
+              <a:bodyPr/>
+              <a:lstStyle/>
+              <a:p>
+                <a:pPr>
+                  <a:defRPr b="0" i="0" strike="noStrike" sz="1100" u="none">
+                    <a:solidFill>
+                      <a:srgbClr val="33475B"/>
+                    </a:solidFill>
+                    <a:latin typeface="Arial"/>
+                  </a:defRPr>
+                </a:pPr>
+              </a:p>
+            </c:txPr>
+            <c:showLegendKey val="0"/>
+            <c:showVal val="1"/>
+            <c:showCatName val="0"/>
+            <c:showSerName val="0"/>
+            <c:showPercent val="0"/>
+            <c:showBubbleSize val="0"/>
+            <c:showLeaderLines val="0"/>
+          </c:dLbls>
+          <c:dPt>
+            <c:idx val="0"/>
+            <c:invertIfNegative val="0"/>
+            <c:bubble3D val="0"/>
+            <c:spPr>
+              <a:solidFill>
+                <a:srgbClr val="1C7293"/>
+              </a:solidFill>
+              <a:effectLst/>
+            </c:spPr>
+          </c:dPt>
+          <c:dPt>
+            <c:idx val="1"/>
+            <c:invertIfNegative val="0"/>
+            <c:bubble3D val="0"/>
+            <c:spPr>
+              <a:solidFill>
+                <a:srgbClr val="1C7293"/>
+              </a:solidFill>
+              <a:effectLst/>
+            </c:spPr>
+          </c:dPt>
+          <c:dPt>
+            <c:idx val="2"/>
+            <c:invertIfNegative val="0"/>
+            <c:bubble3D val="0"/>
+            <c:spPr>
+              <a:solidFill>
+                <a:srgbClr val="1C7293"/>
+              </a:solidFill>
+              <a:effectLst/>
+            </c:spPr>
+          </c:dPt>
+          <c:dPt>
+            <c:idx val="3"/>
+            <c:invertIfNegative val="0"/>
+            <c:bubble3D val="0"/>
+            <c:spPr>
+              <a:solidFill>
+                <a:srgbClr val="1C7293"/>
+              </a:solidFill>
+              <a:effectLst/>
+            </c:spPr>
+          </c:dPt>
+          <c:cat>
+            <c:multiLvlStrRef>
+              <c:f>Sheet1!$A$2:$A$5</c:f>
+              <c:multiLvlStrCache>
+                <c:ptCount val="4"/>
+                <c:lvl>
+                  <c:pt idx="0">
+                    <c:v>GB</c:v>
+                  </c:pt>
+                  <c:pt idx="1">
+                    <c:v>+ tuning</c:v>
+                  </c:pt>
+                  <c:pt idx="2">
+                    <c:v>+ features</c:v>
+                  </c:pt>
+                  <c:pt idx="3">
+                    <c:v>+ neural net</c:v>
+                  </c:pt>
+                </c:lvl>
+              </c:multiLvlStrCache>
+            </c:multiLvlStrRef>
+          </c:cat>
+          <c:val>
+            <c:numRef>
+              <c:f>Sheet1!$B$2:$B$5</c:f>
+              <c:numCache>
+                <c:formatCode>General</c:formatCode>
+                <c:ptCount val="4"/>
+                <c:pt idx="0">
+                  <c:v>0.875</c:v>
+                </c:pt>
+                <c:pt idx="1">
+                  <c:v>0.882</c:v>
+                </c:pt>
+                <c:pt idx="2">
+                  <c:v>0.876</c:v>
+                </c:pt>
+                <c:pt idx="3">
+                  <c:v>0.885</c:v>
+                </c:pt>
+              </c:numCache>
+            </c:numRef>
+          </c:val>
+        </c:ser>
+        <c:dLbls>
+          <c:numFmt formatCode="0.000" sourceLinked="0"/>
+          <c:txPr>
+            <a:bodyPr/>
+            <a:lstStyle/>
+            <a:p>
+              <a:pPr>
+                <a:defRPr b="0" i="0" strike="noStrike" sz="1100" u="none">
+                  <a:solidFill>
+                    <a:srgbClr val="33475B"/>
+                  </a:solidFill>
+                  <a:latin typeface="Arial"/>
+                </a:defRPr>
+              </a:pPr>
+            </a:p>
+          </c:txPr>
+          <c:showLegendKey val="0"/>
+          <c:showVal val="1"/>
+          <c:showCatName val="0"/>
+          <c:showSerName val="0"/>
+          <c:showPercent val="0"/>
+          <c:showBubbleSize val="0"/>
+          <c:showLeaderLines val="0"/>
+        </c:dLbls>
+        <c:gapWidth val="150"/>
+        <c:overlap val="0"/>
+        <c:axId val="2094734554"/>
+        <c:axId val="2094734552"/>
+        <c:axId val="2094734556"/>
+      </c:barChart>
+      <c:catAx>
+        <c:axId val="2094734554"/>
+        <c:scaling>
+          <c:orientation val="minMax"/>
+        </c:scaling>
+        <c:delete val="0"/>
+        <c:axPos val="b"/>
+        <c:numFmt formatCode="General" sourceLinked="1"/>
+        <c:majorTickMark val="out"/>
+        <c:minorTickMark val="none"/>
+        <c:tickLblPos val="low"/>
+        <c:spPr>
+          <a:ln w="12700" cap="flat">
+            <a:solidFill>
+              <a:srgbClr val="888888"/>
+            </a:solidFill>
+            <a:prstDash val="solid"/>
+            <a:round/>
+          </a:ln>
+        </c:spPr>
+        <c:txPr>
+          <a:bodyPr/>
+          <a:lstStyle/>
+          <a:p>
+            <a:pPr>
+              <a:defRPr sz="1100" b="0" i="0" u="none" strike="noStrike">
+                <a:solidFill>
+                  <a:srgbClr val="33475B"/>
+                </a:solidFill>
+                <a:latin typeface="Arial"/>
+              </a:defRPr>
+            </a:pPr>
+            <a:endParaRPr lang="en-US"/>
+          </a:p>
+        </c:txPr>
+        <c:crossAx val="2094734552"/>
+        <c:crosses val="autoZero"/>
+        <c:auto val="1"/>
+        <c:lblAlgn val="ctr"/>
+        <c:noMultiLvlLbl val="1"/>
+      </c:catAx>
+      <c:valAx>
+        <c:axId val="2094734552"/>
+        <c:scaling>
+          <c:orientation val="minMax"/>
+          <c:max val="1"/>
+          <c:min val="0"/>
+        </c:scaling>
+        <c:delete val="1"/>
+        <c:axPos val="l"/>
+        <c:numFmt formatCode="General" sourceLinked="0"/>
+        <c:majorTickMark val="out"/>
+        <c:minorTickMark val="none"/>
+        <c:tickLblPos val="nextTo"/>
+        <c:spPr>
+          <a:ln w="12700" cap="flat">
+            <a:solidFill>
+              <a:srgbClr val="888888"/>
+            </a:solidFill>
+            <a:prstDash val="solid"/>
+            <a:round/>
+          </a:ln>
+        </c:spPr>
+        <c:txPr>
+          <a:bodyPr/>
+          <a:lstStyle/>
+          <a:p>
+            <a:pPr>
+              <a:defRPr sz="1200" b="0" i="0" u="none" strike="noStrike">
+                <a:solidFill>
+                  <a:srgbClr val="000000"/>
+                </a:solidFill>
+                <a:latin typeface="Arial"/>
+              </a:defRPr>
+            </a:pPr>
+            <a:endParaRPr lang="en-US"/>
+          </a:p>
+        </c:txPr>
+        <c:crossAx val="2094734554"/>
+        <c:crosses val="autoZero"/>
+        <c:crossBetween val="between"/>
+      </c:valAx>
+      <c:spPr>
+        <a:noFill/>
+        <a:ln>
+          <a:noFill/>
+        </a:ln>
+        <a:effectLst/>
+      </c:spPr>
+    </c:plotArea>
+    <c:plotVisOnly val="1"/>
+    <c:dispBlanksAs val="span"/>
+  </c:chart>
+  <c:spPr>
+    <a:noFill/>
+    <a:ln>
+      <a:noFill/>
+    </a:ln>
+    <a:effectLst/>
+  </c:spPr>
+  <c:externalData r:id="rId1">
+    <c:autoUpdate val="0"/>
+  </c:externalData>
+</c:chartSpace>
+</file>
+
 <file path=ppt/notesMasters/notesMaster1.xml><?xml version="1.0" encoding="utf-8"?>
 <p:notesMaster xmlns:a="http://schemas.openxmlformats.org/drawingml/2006/main" xmlns:r="http://schemas.openxmlformats.org/officeDocument/2006/relationships" xmlns:p="http://schemas.openxmlformats.org/presentationml/2006/main">
   <p:cSld>
@@ -2560,6 +2843,182 @@
             <a:fld id="{F7021451-1387-4CA6-816F-3879F97B5CBC}" type="slidenum">
               <a:rPr lang="en-US"/>
               <a:t>17</a:t>
+            </a:fld>
+            <a:endParaRPr lang="en-US"/>
+          </a:p>
+        </p:txBody>
+      </p:sp>
+    </p:spTree>
+    <p:extLst>
+      <p:ext uri="{BB962C8B-B14F-4D97-AF65-F5344CB8AC3E}">
+        <p14:creationId xmlns:p14="http://schemas.microsoft.com/office/powerpoint/2010/main" val="1024086991"/>
+      </p:ext>
+    </p:extLst>
+  </p:cSld>
+  <p:clrMapOvr>
+    <a:masterClrMapping/>
+  </p:clrMapOvr>
+</p:notes>
+</file>
+
+<file path=ppt/notesSlides/notesSlide18.xml><?xml version="1.0" encoding="utf-8"?>
+<p:notes xmlns:a="http://schemas.openxmlformats.org/drawingml/2006/main" xmlns:r="http://schemas.openxmlformats.org/officeDocument/2006/relationships" xmlns:p="http://schemas.openxmlformats.org/presentationml/2006/main">
+  <p:cSld>
+    <p:spTree>
+      <p:nvGrpSpPr>
+        <p:cNvPr id="1" name=""/>
+        <p:cNvGrpSpPr/>
+        <p:nvPr/>
+      </p:nvGrpSpPr>
+      <p:grpSpPr>
+        <a:xfrm>
+          <a:off x="0" y="0"/>
+          <a:ext cx="0" cy="0"/>
+          <a:chOff x="0" y="0"/>
+          <a:chExt cx="0" cy="0"/>
+        </a:xfrm>
+      </p:grpSpPr>
+      <p:sp>
+        <p:nvSpPr>
+          <p:cNvPr id="2" name="Slide Image Placeholder 1"/>
+          <p:cNvSpPr>
+            <a:spLocks noGrp="1" noRot="1" noChangeAspect="1"/>
+          </p:cNvSpPr>
+          <p:nvPr>
+            <p:ph type="sldImg"/>
+          </p:nvPr>
+        </p:nvSpPr>
+        <p:spPr/>
+      </p:sp>
+      <p:sp>
+        <p:nvSpPr>
+          <p:cNvPr id="3" name="Notes Placeholder 2"/>
+          <p:cNvSpPr>
+            <a:spLocks noGrp="1"/>
+          </p:cNvSpPr>
+          <p:nvPr>
+            <p:ph type="body" idx="1"/>
+          </p:nvPr>
+        </p:nvSpPr>
+        <p:spPr/>
+        <p:txBody>
+          <a:bodyPr/>
+          <a:lstStyle/>
+          <a:p>
+            <a:r>
+              <a:rPr lang="en-US" dirty="0"/>
+              <a:t/>
+            </a:r>
+            <a:endParaRPr lang="en-US" dirty="0"/>
+          </a:p>
+        </p:txBody>
+      </p:sp>
+      <p:sp>
+        <p:nvSpPr>
+          <p:cNvPr id="4" name="Slide Number Placeholder 3"/>
+          <p:cNvSpPr>
+            <a:spLocks noGrp="1"/>
+          </p:cNvSpPr>
+          <p:nvPr>
+            <p:ph type="sldNum" sz="quarter" idx="10"/>
+          </p:nvPr>
+        </p:nvSpPr>
+        <p:spPr/>
+        <p:txBody>
+          <a:bodyPr/>
+          <a:lstStyle/>
+          <a:p>
+            <a:fld id="{F7021451-1387-4CA6-816F-3879F97B5CBC}" type="slidenum">
+              <a:rPr lang="en-US"/>
+              <a:t>18</a:t>
+            </a:fld>
+            <a:endParaRPr lang="en-US"/>
+          </a:p>
+        </p:txBody>
+      </p:sp>
+    </p:spTree>
+    <p:extLst>
+      <p:ext uri="{BB962C8B-B14F-4D97-AF65-F5344CB8AC3E}">
+        <p14:creationId xmlns:p14="http://schemas.microsoft.com/office/powerpoint/2010/main" val="1024086991"/>
+      </p:ext>
+    </p:extLst>
+  </p:cSld>
+  <p:clrMapOvr>
+    <a:masterClrMapping/>
+  </p:clrMapOvr>
+</p:notes>
+</file>
+
+<file path=ppt/notesSlides/notesSlide19.xml><?xml version="1.0" encoding="utf-8"?>
+<p:notes xmlns:a="http://schemas.openxmlformats.org/drawingml/2006/main" xmlns:r="http://schemas.openxmlformats.org/officeDocument/2006/relationships" xmlns:p="http://schemas.openxmlformats.org/presentationml/2006/main">
+  <p:cSld>
+    <p:spTree>
+      <p:nvGrpSpPr>
+        <p:cNvPr id="1" name=""/>
+        <p:cNvGrpSpPr/>
+        <p:nvPr/>
+      </p:nvGrpSpPr>
+      <p:grpSpPr>
+        <a:xfrm>
+          <a:off x="0" y="0"/>
+          <a:ext cx="0" cy="0"/>
+          <a:chOff x="0" y="0"/>
+          <a:chExt cx="0" cy="0"/>
+        </a:xfrm>
+      </p:grpSpPr>
+      <p:sp>
+        <p:nvSpPr>
+          <p:cNvPr id="2" name="Slide Image Placeholder 1"/>
+          <p:cNvSpPr>
+            <a:spLocks noGrp="1" noRot="1" noChangeAspect="1"/>
+          </p:cNvSpPr>
+          <p:nvPr>
+            <p:ph type="sldImg"/>
+          </p:nvPr>
+        </p:nvSpPr>
+        <p:spPr/>
+      </p:sp>
+      <p:sp>
+        <p:nvSpPr>
+          <p:cNvPr id="3" name="Notes Placeholder 2"/>
+          <p:cNvSpPr>
+            <a:spLocks noGrp="1"/>
+          </p:cNvSpPr>
+          <p:nvPr>
+            <p:ph type="body" idx="1"/>
+          </p:nvPr>
+        </p:nvSpPr>
+        <p:spPr/>
+        <p:txBody>
+          <a:bodyPr/>
+          <a:lstStyle/>
+          <a:p>
+            <a:r>
+              <a:rPr lang="en-US" dirty="0"/>
+              <a:t/>
+            </a:r>
+            <a:endParaRPr lang="en-US" dirty="0"/>
+          </a:p>
+        </p:txBody>
+      </p:sp>
+      <p:sp>
+        <p:nvSpPr>
+          <p:cNvPr id="4" name="Slide Number Placeholder 3"/>
+          <p:cNvSpPr>
+            <a:spLocks noGrp="1"/>
+          </p:cNvSpPr>
+          <p:nvPr>
+            <p:ph type="sldNum" sz="quarter" idx="10"/>
+          </p:nvPr>
+        </p:nvSpPr>
+        <p:spPr/>
+        <p:txBody>
+          <a:bodyPr/>
+          <a:lstStyle/>
+          <a:p>
+            <a:fld id="{F7021451-1387-4CA6-816F-3879F97B5CBC}" type="slidenum">
+              <a:rPr lang="en-US"/>
+              <a:t>19</a:t>
             </a:fld>
             <a:endParaRPr lang="en-US"/>
           </a:p>
@@ -12428,6 +12887,2680 @@
     <p:bg>
       <p:bgPr>
         <a:solidFill>
+          <a:srgbClr val="FFFFFF"/>
+        </a:solidFill>
+      </p:bgPr>
+    </p:bg>
+    <p:spTree>
+      <p:nvGrpSpPr>
+        <p:cNvPr id="1" name=""/>
+        <p:cNvGrpSpPr/>
+        <p:nvPr/>
+      </p:nvGrpSpPr>
+      <p:grpSpPr>
+        <a:xfrm>
+          <a:off x="0" y="0"/>
+          <a:ext cx="0" cy="0"/>
+          <a:chOff x="0" y="0"/>
+          <a:chExt cx="0" cy="0"/>
+        </a:xfrm>
+      </p:grpSpPr>
+      <p:sp>
+        <p:nvSpPr>
+          <p:cNvPr id="2" name="Shape 0"/>
+          <p:cNvSpPr/>
+          <p:nvPr/>
+        </p:nvSpPr>
+        <p:spPr>
+          <a:xfrm>
+            <a:off x="457200" y="384048"/>
+            <a:ext cx="1417320" cy="384048"/>
+          </a:xfrm>
+          <a:prstGeom prst="roundRect">
+            <a:avLst>
+              <a:gd name="adj" fmla="val 19048"/>
+            </a:avLst>
+          </a:prstGeom>
+          <a:solidFill>
+            <a:srgbClr val="C0392B"/>
+          </a:solidFill>
+          <a:ln/>
+        </p:spPr>
+      </p:sp>
+      <p:sp>
+        <p:nvSpPr>
+          <p:cNvPr id="3" name="Text 1"/>
+          <p:cNvSpPr/>
+          <p:nvPr/>
+        </p:nvSpPr>
+        <p:spPr>
+          <a:xfrm>
+            <a:off x="457200" y="384048"/>
+            <a:ext cx="1417320" cy="384048"/>
+          </a:xfrm>
+          <a:prstGeom prst="rect">
+            <a:avLst/>
+          </a:prstGeom>
+          <a:noFill/>
+          <a:ln/>
+        </p:spPr>
+        <p:txBody>
+          <a:bodyPr wrap="square" lIns="0" tIns="0" rIns="0" bIns="0" rtlCol="0" anchor="ctr"/>
+          <a:lstStyle/>
+          <a:p>
+            <a:pPr algn="ctr" indent="0" marL="0">
+              <a:buNone/>
+            </a:pPr>
+            <a:r>
+              <a:rPr lang="en-US" sz="1300" b="1" dirty="0">
+                <a:solidFill>
+                  <a:srgbClr val="FFFFFF"/>
+                </a:solidFill>
+                <a:latin typeface="Consolas" pitchFamily="34" charset="0"/>
+                <a:ea typeface="Consolas" pitchFamily="34" charset="-122"/>
+                <a:cs typeface="Consolas" pitchFamily="34" charset="-120"/>
+              </a:rPr>
+              <a:t>RIGOR</a:t>
+            </a:r>
+            <a:endParaRPr lang="en-US" sz="1300" dirty="0"/>
+          </a:p>
+        </p:txBody>
+      </p:sp>
+      <p:sp>
+        <p:nvSpPr>
+          <p:cNvPr id="4" name="Text 2"/>
+          <p:cNvSpPr/>
+          <p:nvPr/>
+        </p:nvSpPr>
+        <p:spPr>
+          <a:xfrm>
+            <a:off x="457200" y="868680"/>
+            <a:ext cx="11274552" cy="566928"/>
+          </a:xfrm>
+          <a:prstGeom prst="rect">
+            <a:avLst/>
+          </a:prstGeom>
+          <a:noFill/>
+          <a:ln/>
+        </p:spPr>
+        <p:txBody>
+          <a:bodyPr wrap="square" lIns="0" tIns="0" rIns="0" bIns="0" rtlCol="0" anchor="ctr"/>
+          <a:lstStyle/>
+          <a:p>
+            <a:pPr indent="0" marL="0">
+              <a:buNone/>
+            </a:pPr>
+            <a:r>
+              <a:rPr lang="en-US" sz="2800" b="1" dirty="0">
+                <a:solidFill>
+                  <a:srgbClr val="0F2C3F"/>
+                </a:solidFill>
+                <a:latin typeface="Georgia" pitchFamily="34" charset="0"/>
+                <a:ea typeface="Georgia" pitchFamily="34" charset="-122"/>
+                <a:cs typeface="Georgia" pitchFamily="34" charset="-120"/>
+              </a:rPr>
+              <a:t>Beyond the Baseline — Did We Leave Accuracy on the Table?</a:t>
+            </a:r>
+            <a:endParaRPr lang="en-US" sz="2800" dirty="0"/>
+          </a:p>
+        </p:txBody>
+      </p:sp>
+      <p:sp>
+        <p:nvSpPr>
+          <p:cNvPr id="5" name="Text 3"/>
+          <p:cNvSpPr/>
+          <p:nvPr/>
+        </p:nvSpPr>
+        <p:spPr>
+          <a:xfrm>
+            <a:off x="457200" y="1417320"/>
+            <a:ext cx="11274552" cy="365760"/>
+          </a:xfrm>
+          <a:prstGeom prst="rect">
+            <a:avLst/>
+          </a:prstGeom>
+          <a:noFill/>
+          <a:ln/>
+        </p:spPr>
+        <p:txBody>
+          <a:bodyPr wrap="square" lIns="0" tIns="0" rIns="0" bIns="0" rtlCol="0" anchor="ctr"/>
+          <a:lstStyle/>
+          <a:p>
+            <a:pPr indent="0" marL="0">
+              <a:buNone/>
+            </a:pPr>
+            <a:r>
+              <a:rPr lang="en-US" sz="1400" i="1" dirty="0">
+                <a:solidFill>
+                  <a:srgbClr val="70819A"/>
+                </a:solidFill>
+              </a:rPr>
+              <a:t>Three independent attempts to beat Gradient Boosting, all cross-validated</a:t>
+            </a:r>
+            <a:endParaRPr lang="en-US" sz="1400" dirty="0"/>
+          </a:p>
+        </p:txBody>
+      </p:sp>
+      <p:graphicFrame>
+        <p:nvGraphicFramePr>
+          <p:cNvPr id="18" name="Table 0"/>
+          <p:cNvGraphicFramePr>
+            <a:graphicFrameLocks noGrp="1"/>
+          </p:cNvGraphicFramePr>
+          <p:nvPr>
+            <p:extLst>
+              <p:ext uri="{D42A27DB-BD31-4B8C-83A1-F6EECF244321}">
+                <p14:modId xmlns:p14="http://schemas.microsoft.com/office/powerpoint/2010/main" val="1579011935"/>
+              </p:ext>
+            </p:extLst>
+          </p:nvPr>
+        </p:nvGraphicFramePr>
+        <p:xfrm>
+          <a:off x="457200" y="1874520"/>
+          <a:ext cx="11274552" cy="914400"/>
+        </p:xfrm>
+        <a:graphic>
+          <a:graphicData uri="http://schemas.openxmlformats.org/drawingml/2006/table">
+            <a:tbl>
+              <a:tblPr/>
+              <a:tblGrid>
+                <a:gridCol w="3383280"/>
+                <a:gridCol w="1371600"/>
+                <a:gridCol w="1371600"/>
+                <a:gridCol w="1371600"/>
+                <a:gridCol w="1463040"/>
+                <a:gridCol w="2313432"/>
+              </a:tblGrid>
+              <a:tr h="475488">
+                <a:tc>
+                  <a:txBody>
+                    <a:bodyPr/>
+                    <a:lstStyle/>
+                    <a:p>
+                      <a:pPr algn="ctr" indent="0" marL="0">
+                        <a:buNone/>
+                      </a:pPr>
+                      <a:r>
+                        <a:rPr lang="en-US" sz="1100" b="1" dirty="0">
+                          <a:solidFill>
+                            <a:srgbClr val="FFFFFF"/>
+                          </a:solidFill>
+                        </a:rPr>
+                        <a:t>Approach</a:t>
+                      </a:r>
+                      <a:endParaRPr lang="en-US" sz="1100" dirty="0"/>
+                    </a:p>
+                  </a:txBody>
+                  <a:tcPr marL="91440" marR="91440" marT="45720" marB="45720" anchor="ctr">
+                    <a:lnL w="6350" cap="flat" cmpd="sng" algn="ctr">
+                      <a:solidFill>
+                        <a:srgbClr val="D9E2EC"/>
+                      </a:solidFill>
+                      <a:prstDash val="solid"/>
+                      <a:round/>
+                      <a:headEnd type="none" w="med" len="med"/>
+                      <a:tailEnd type="none" w="med" len="med"/>
+                    </a:lnL>
+                    <a:lnR w="6350" cap="flat" cmpd="sng" algn="ctr">
+                      <a:solidFill>
+                        <a:srgbClr val="D9E2EC"/>
+                      </a:solidFill>
+                      <a:prstDash val="solid"/>
+                      <a:round/>
+                      <a:headEnd type="none" w="med" len="med"/>
+                      <a:tailEnd type="none" w="med" len="med"/>
+                    </a:lnR>
+                    <a:lnT w="6350" cap="flat" cmpd="sng" algn="ctr">
+                      <a:solidFill>
+                        <a:srgbClr val="D9E2EC"/>
+                      </a:solidFill>
+                      <a:prstDash val="solid"/>
+                      <a:round/>
+                      <a:headEnd type="none" w="med" len="med"/>
+                      <a:tailEnd type="none" w="med" len="med"/>
+                    </a:lnT>
+                    <a:lnB w="6350" cap="flat" cmpd="sng" algn="ctr">
+                      <a:solidFill>
+                        <a:srgbClr val="D9E2EC"/>
+                      </a:solidFill>
+                      <a:prstDash val="solid"/>
+                      <a:round/>
+                      <a:headEnd type="none" w="med" len="med"/>
+                      <a:tailEnd type="none" w="med" len="med"/>
+                    </a:lnB>
+                    <a:solidFill>
+                      <a:srgbClr val="0F2C3F"/>
+                    </a:solidFill>
+                  </a:tcPr>
+                </a:tc>
+                <a:tc>
+                  <a:txBody>
+                    <a:bodyPr/>
+                    <a:lstStyle/>
+                    <a:p>
+                      <a:pPr algn="ctr" indent="0" marL="0">
+                        <a:buNone/>
+                      </a:pPr>
+                      <a:r>
+                        <a:rPr lang="en-US" sz="1100" b="1" dirty="0">
+                          <a:solidFill>
+                            <a:srgbClr val="FFFFFF"/>
+                          </a:solidFill>
+                        </a:rPr>
+                        <a:t>CV AUC</a:t>
+                      </a:r>
+                      <a:endParaRPr lang="en-US" sz="1100" dirty="0"/>
+                    </a:p>
+                  </a:txBody>
+                  <a:tcPr marL="91440" marR="91440" marT="45720" marB="45720" anchor="ctr">
+                    <a:lnL w="6350" cap="flat" cmpd="sng" algn="ctr">
+                      <a:solidFill>
+                        <a:srgbClr val="D9E2EC"/>
+                      </a:solidFill>
+                      <a:prstDash val="solid"/>
+                      <a:round/>
+                      <a:headEnd type="none" w="med" len="med"/>
+                      <a:tailEnd type="none" w="med" len="med"/>
+                    </a:lnL>
+                    <a:lnR w="6350" cap="flat" cmpd="sng" algn="ctr">
+                      <a:solidFill>
+                        <a:srgbClr val="D9E2EC"/>
+                      </a:solidFill>
+                      <a:prstDash val="solid"/>
+                      <a:round/>
+                      <a:headEnd type="none" w="med" len="med"/>
+                      <a:tailEnd type="none" w="med" len="med"/>
+                    </a:lnR>
+                    <a:lnT w="6350" cap="flat" cmpd="sng" algn="ctr">
+                      <a:solidFill>
+                        <a:srgbClr val="D9E2EC"/>
+                      </a:solidFill>
+                      <a:prstDash val="solid"/>
+                      <a:round/>
+                      <a:headEnd type="none" w="med" len="med"/>
+                      <a:tailEnd type="none" w="med" len="med"/>
+                    </a:lnT>
+                    <a:lnB w="6350" cap="flat" cmpd="sng" algn="ctr">
+                      <a:solidFill>
+                        <a:srgbClr val="D9E2EC"/>
+                      </a:solidFill>
+                      <a:prstDash val="solid"/>
+                      <a:round/>
+                      <a:headEnd type="none" w="med" len="med"/>
+                      <a:tailEnd type="none" w="med" len="med"/>
+                    </a:lnB>
+                    <a:solidFill>
+                      <a:srgbClr val="0F2C3F"/>
+                    </a:solidFill>
+                  </a:tcPr>
+                </a:tc>
+                <a:tc>
+                  <a:txBody>
+                    <a:bodyPr/>
+                    <a:lstStyle/>
+                    <a:p>
+                      <a:pPr algn="ctr" indent="0" marL="0">
+                        <a:buNone/>
+                      </a:pPr>
+                      <a:r>
+                        <a:rPr lang="en-US" sz="1100" b="1" dirty="0">
+                          <a:solidFill>
+                            <a:srgbClr val="FFFFFF"/>
+                          </a:solidFill>
+                        </a:rPr>
+                        <a:t>Test AUC</a:t>
+                      </a:r>
+                      <a:endParaRPr lang="en-US" sz="1100" dirty="0"/>
+                    </a:p>
+                  </a:txBody>
+                  <a:tcPr marL="91440" marR="91440" marT="45720" marB="45720" anchor="ctr">
+                    <a:lnL w="6350" cap="flat" cmpd="sng" algn="ctr">
+                      <a:solidFill>
+                        <a:srgbClr val="D9E2EC"/>
+                      </a:solidFill>
+                      <a:prstDash val="solid"/>
+                      <a:round/>
+                      <a:headEnd type="none" w="med" len="med"/>
+                      <a:tailEnd type="none" w="med" len="med"/>
+                    </a:lnL>
+                    <a:lnR w="6350" cap="flat" cmpd="sng" algn="ctr">
+                      <a:solidFill>
+                        <a:srgbClr val="D9E2EC"/>
+                      </a:solidFill>
+                      <a:prstDash val="solid"/>
+                      <a:round/>
+                      <a:headEnd type="none" w="med" len="med"/>
+                      <a:tailEnd type="none" w="med" len="med"/>
+                    </a:lnR>
+                    <a:lnT w="6350" cap="flat" cmpd="sng" algn="ctr">
+                      <a:solidFill>
+                        <a:srgbClr val="D9E2EC"/>
+                      </a:solidFill>
+                      <a:prstDash val="solid"/>
+                      <a:round/>
+                      <a:headEnd type="none" w="med" len="med"/>
+                      <a:tailEnd type="none" w="med" len="med"/>
+                    </a:lnT>
+                    <a:lnB w="6350" cap="flat" cmpd="sng" algn="ctr">
+                      <a:solidFill>
+                        <a:srgbClr val="D9E2EC"/>
+                      </a:solidFill>
+                      <a:prstDash val="solid"/>
+                      <a:round/>
+                      <a:headEnd type="none" w="med" len="med"/>
+                      <a:tailEnd type="none" w="med" len="med"/>
+                    </a:lnB>
+                    <a:solidFill>
+                      <a:srgbClr val="0F2C3F"/>
+                    </a:solidFill>
+                  </a:tcPr>
+                </a:tc>
+                <a:tc>
+                  <a:txBody>
+                    <a:bodyPr/>
+                    <a:lstStyle/>
+                    <a:p>
+                      <a:pPr algn="ctr" indent="0" marL="0">
+                        <a:buNone/>
+                      </a:pPr>
+                      <a:r>
+                        <a:rPr lang="en-US" sz="1100" b="1" dirty="0">
+                          <a:solidFill>
+                            <a:srgbClr val="FFFFFF"/>
+                          </a:solidFill>
+                        </a:rPr>
+                        <a:t>Test Acc</a:t>
+                      </a:r>
+                      <a:endParaRPr lang="en-US" sz="1100" dirty="0"/>
+                    </a:p>
+                  </a:txBody>
+                  <a:tcPr marL="91440" marR="91440" marT="45720" marB="45720" anchor="ctr">
+                    <a:lnL w="6350" cap="flat" cmpd="sng" algn="ctr">
+                      <a:solidFill>
+                        <a:srgbClr val="D9E2EC"/>
+                      </a:solidFill>
+                      <a:prstDash val="solid"/>
+                      <a:round/>
+                      <a:headEnd type="none" w="med" len="med"/>
+                      <a:tailEnd type="none" w="med" len="med"/>
+                    </a:lnL>
+                    <a:lnR w="6350" cap="flat" cmpd="sng" algn="ctr">
+                      <a:solidFill>
+                        <a:srgbClr val="D9E2EC"/>
+                      </a:solidFill>
+                      <a:prstDash val="solid"/>
+                      <a:round/>
+                      <a:headEnd type="none" w="med" len="med"/>
+                      <a:tailEnd type="none" w="med" len="med"/>
+                    </a:lnR>
+                    <a:lnT w="6350" cap="flat" cmpd="sng" algn="ctr">
+                      <a:solidFill>
+                        <a:srgbClr val="D9E2EC"/>
+                      </a:solidFill>
+                      <a:prstDash val="solid"/>
+                      <a:round/>
+                      <a:headEnd type="none" w="med" len="med"/>
+                      <a:tailEnd type="none" w="med" len="med"/>
+                    </a:lnT>
+                    <a:lnB w="6350" cap="flat" cmpd="sng" algn="ctr">
+                      <a:solidFill>
+                        <a:srgbClr val="D9E2EC"/>
+                      </a:solidFill>
+                      <a:prstDash val="solid"/>
+                      <a:round/>
+                      <a:headEnd type="none" w="med" len="med"/>
+                      <a:tailEnd type="none" w="med" len="med"/>
+                    </a:lnB>
+                    <a:solidFill>
+                      <a:srgbClr val="0F2C3F"/>
+                    </a:solidFill>
+                  </a:tcPr>
+                </a:tc>
+                <a:tc>
+                  <a:txBody>
+                    <a:bodyPr/>
+                    <a:lstStyle/>
+                    <a:p>
+                      <a:pPr algn="ctr" indent="0" marL="0">
+                        <a:buNone/>
+                      </a:pPr>
+                      <a:r>
+                        <a:rPr lang="en-US" sz="1100" b="1" dirty="0">
+                          <a:solidFill>
+                            <a:srgbClr val="FFFFFF"/>
+                          </a:solidFill>
+                        </a:rPr>
+                        <a:t>Test Recall</a:t>
+                      </a:r>
+                      <a:endParaRPr lang="en-US" sz="1100" dirty="0"/>
+                    </a:p>
+                  </a:txBody>
+                  <a:tcPr marL="91440" marR="91440" marT="45720" marB="45720" anchor="ctr">
+                    <a:lnL w="6350" cap="flat" cmpd="sng" algn="ctr">
+                      <a:solidFill>
+                        <a:srgbClr val="D9E2EC"/>
+                      </a:solidFill>
+                      <a:prstDash val="solid"/>
+                      <a:round/>
+                      <a:headEnd type="none" w="med" len="med"/>
+                      <a:tailEnd type="none" w="med" len="med"/>
+                    </a:lnL>
+                    <a:lnR w="6350" cap="flat" cmpd="sng" algn="ctr">
+                      <a:solidFill>
+                        <a:srgbClr val="D9E2EC"/>
+                      </a:solidFill>
+                      <a:prstDash val="solid"/>
+                      <a:round/>
+                      <a:headEnd type="none" w="med" len="med"/>
+                      <a:tailEnd type="none" w="med" len="med"/>
+                    </a:lnR>
+                    <a:lnT w="6350" cap="flat" cmpd="sng" algn="ctr">
+                      <a:solidFill>
+                        <a:srgbClr val="D9E2EC"/>
+                      </a:solidFill>
+                      <a:prstDash val="solid"/>
+                      <a:round/>
+                      <a:headEnd type="none" w="med" len="med"/>
+                      <a:tailEnd type="none" w="med" len="med"/>
+                    </a:lnT>
+                    <a:lnB w="6350" cap="flat" cmpd="sng" algn="ctr">
+                      <a:solidFill>
+                        <a:srgbClr val="D9E2EC"/>
+                      </a:solidFill>
+                      <a:prstDash val="solid"/>
+                      <a:round/>
+                      <a:headEnd type="none" w="med" len="med"/>
+                      <a:tailEnd type="none" w="med" len="med"/>
+                    </a:lnB>
+                    <a:solidFill>
+                      <a:srgbClr val="0F2C3F"/>
+                    </a:solidFill>
+                  </a:tcPr>
+                </a:tc>
+                <a:tc>
+                  <a:txBody>
+                    <a:bodyPr/>
+                    <a:lstStyle/>
+                    <a:p>
+                      <a:pPr algn="ctr" indent="0" marL="0">
+                        <a:buNone/>
+                      </a:pPr>
+                      <a:r>
+                        <a:rPr lang="en-US" sz="1100" b="1" dirty="0">
+                          <a:solidFill>
+                            <a:srgbClr val="FFFFFF"/>
+                          </a:solidFill>
+                        </a:rPr>
+                        <a:t>Outcome</a:t>
+                      </a:r>
+                      <a:endParaRPr lang="en-US" sz="1100" dirty="0"/>
+                    </a:p>
+                  </a:txBody>
+                  <a:tcPr marL="91440" marR="91440" marT="45720" marB="45720" anchor="ctr">
+                    <a:lnL w="6350" cap="flat" cmpd="sng" algn="ctr">
+                      <a:solidFill>
+                        <a:srgbClr val="D9E2EC"/>
+                      </a:solidFill>
+                      <a:prstDash val="solid"/>
+                      <a:round/>
+                      <a:headEnd type="none" w="med" len="med"/>
+                      <a:tailEnd type="none" w="med" len="med"/>
+                    </a:lnL>
+                    <a:lnR w="6350" cap="flat" cmpd="sng" algn="ctr">
+                      <a:solidFill>
+                        <a:srgbClr val="D9E2EC"/>
+                      </a:solidFill>
+                      <a:prstDash val="solid"/>
+                      <a:round/>
+                      <a:headEnd type="none" w="med" len="med"/>
+                      <a:tailEnd type="none" w="med" len="med"/>
+                    </a:lnR>
+                    <a:lnT w="6350" cap="flat" cmpd="sng" algn="ctr">
+                      <a:solidFill>
+                        <a:srgbClr val="D9E2EC"/>
+                      </a:solidFill>
+                      <a:prstDash val="solid"/>
+                      <a:round/>
+                      <a:headEnd type="none" w="med" len="med"/>
+                      <a:tailEnd type="none" w="med" len="med"/>
+                    </a:lnT>
+                    <a:lnB w="6350" cap="flat" cmpd="sng" algn="ctr">
+                      <a:solidFill>
+                        <a:srgbClr val="D9E2EC"/>
+                      </a:solidFill>
+                      <a:prstDash val="solid"/>
+                      <a:round/>
+                      <a:headEnd type="none" w="med" len="med"/>
+                      <a:tailEnd type="none" w="med" len="med"/>
+                    </a:lnB>
+                    <a:solidFill>
+                      <a:srgbClr val="0F2C3F"/>
+                    </a:solidFill>
+                  </a:tcPr>
+                </a:tc>
+              </a:tr>
+              <a:tr h="475488">
+                <a:tc>
+                  <a:txBody>
+                    <a:bodyPr/>
+                    <a:lstStyle/>
+                    <a:p>
+                      <a:pPr algn="l" indent="0" marL="0">
+                        <a:buNone/>
+                      </a:pPr>
+                      <a:r>
+                        <a:rPr lang="en-US" sz="1200" b="1" dirty="0">
+                          <a:solidFill>
+                            <a:srgbClr val="0F2C3F"/>
+                          </a:solidFill>
+                        </a:rPr>
+                        <a:t>Gradient Boosting (chosen)  ✓</a:t>
+                      </a:r>
+                      <a:endParaRPr lang="en-US" sz="1200" dirty="0"/>
+                    </a:p>
+                  </a:txBody>
+                  <a:tcPr marL="91440" marR="91440" marT="45720" marB="45720" anchor="ctr">
+                    <a:lnL w="6350" cap="flat" cmpd="sng" algn="ctr">
+                      <a:solidFill>
+                        <a:srgbClr val="D9E2EC"/>
+                      </a:solidFill>
+                      <a:prstDash val="solid"/>
+                      <a:round/>
+                      <a:headEnd type="none" w="med" len="med"/>
+                      <a:tailEnd type="none" w="med" len="med"/>
+                    </a:lnL>
+                    <a:lnR w="6350" cap="flat" cmpd="sng" algn="ctr">
+                      <a:solidFill>
+                        <a:srgbClr val="D9E2EC"/>
+                      </a:solidFill>
+                      <a:prstDash val="solid"/>
+                      <a:round/>
+                      <a:headEnd type="none" w="med" len="med"/>
+                      <a:tailEnd type="none" w="med" len="med"/>
+                    </a:lnR>
+                    <a:lnT w="6350" cap="flat" cmpd="sng" algn="ctr">
+                      <a:solidFill>
+                        <a:srgbClr val="D9E2EC"/>
+                      </a:solidFill>
+                      <a:prstDash val="solid"/>
+                      <a:round/>
+                      <a:headEnd type="none" w="med" len="med"/>
+                      <a:tailEnd type="none" w="med" len="med"/>
+                    </a:lnT>
+                    <a:lnB w="6350" cap="flat" cmpd="sng" algn="ctr">
+                      <a:solidFill>
+                        <a:srgbClr val="D9E2EC"/>
+                      </a:solidFill>
+                      <a:prstDash val="solid"/>
+                      <a:round/>
+                      <a:headEnd type="none" w="med" len="med"/>
+                      <a:tailEnd type="none" w="med" len="med"/>
+                    </a:lnB>
+                    <a:solidFill>
+                      <a:srgbClr val="E7F0E9"/>
+                    </a:solidFill>
+                  </a:tcPr>
+                </a:tc>
+                <a:tc>
+                  <a:txBody>
+                    <a:bodyPr/>
+                    <a:lstStyle/>
+                    <a:p>
+                      <a:pPr algn="ctr" indent="0" marL="0">
+                        <a:buNone/>
+                      </a:pPr>
+                      <a:r>
+                        <a:rPr lang="en-US" sz="1100" dirty="0">
+                          <a:solidFill>
+                            <a:srgbClr val="33475B"/>
+                          </a:solidFill>
+                        </a:rPr>
+                        <a:t>0.875</a:t>
+                      </a:r>
+                      <a:endParaRPr lang="en-US" sz="1100" dirty="0"/>
+                    </a:p>
+                  </a:txBody>
+                  <a:tcPr marL="91440" marR="91440" marT="45720" marB="45720" anchor="ctr">
+                    <a:lnL w="6350" cap="flat" cmpd="sng" algn="ctr">
+                      <a:solidFill>
+                        <a:srgbClr val="D9E2EC"/>
+                      </a:solidFill>
+                      <a:prstDash val="solid"/>
+                      <a:round/>
+                      <a:headEnd type="none" w="med" len="med"/>
+                      <a:tailEnd type="none" w="med" len="med"/>
+                    </a:lnL>
+                    <a:lnR w="6350" cap="flat" cmpd="sng" algn="ctr">
+                      <a:solidFill>
+                        <a:srgbClr val="D9E2EC"/>
+                      </a:solidFill>
+                      <a:prstDash val="solid"/>
+                      <a:round/>
+                      <a:headEnd type="none" w="med" len="med"/>
+                      <a:tailEnd type="none" w="med" len="med"/>
+                    </a:lnR>
+                    <a:lnT w="6350" cap="flat" cmpd="sng" algn="ctr">
+                      <a:solidFill>
+                        <a:srgbClr val="D9E2EC"/>
+                      </a:solidFill>
+                      <a:prstDash val="solid"/>
+                      <a:round/>
+                      <a:headEnd type="none" w="med" len="med"/>
+                      <a:tailEnd type="none" w="med" len="med"/>
+                    </a:lnT>
+                    <a:lnB w="6350" cap="flat" cmpd="sng" algn="ctr">
+                      <a:solidFill>
+                        <a:srgbClr val="D9E2EC"/>
+                      </a:solidFill>
+                      <a:prstDash val="solid"/>
+                      <a:round/>
+                      <a:headEnd type="none" w="med" len="med"/>
+                      <a:tailEnd type="none" w="med" len="med"/>
+                    </a:lnB>
+                    <a:solidFill>
+                      <a:srgbClr val="E7F0E9"/>
+                    </a:solidFill>
+                  </a:tcPr>
+                </a:tc>
+                <a:tc>
+                  <a:txBody>
+                    <a:bodyPr/>
+                    <a:lstStyle/>
+                    <a:p>
+                      <a:pPr algn="ctr" indent="0" marL="0">
+                        <a:buNone/>
+                      </a:pPr>
+                      <a:r>
+                        <a:rPr lang="en-US" sz="1100" dirty="0">
+                          <a:solidFill>
+                            <a:srgbClr val="33475B"/>
+                          </a:solidFill>
+                        </a:rPr>
+                        <a:t>0.908</a:t>
+                      </a:r>
+                      <a:endParaRPr lang="en-US" sz="1100" dirty="0"/>
+                    </a:p>
+                  </a:txBody>
+                  <a:tcPr marL="91440" marR="91440" marT="45720" marB="45720" anchor="ctr">
+                    <a:lnL w="6350" cap="flat" cmpd="sng" algn="ctr">
+                      <a:solidFill>
+                        <a:srgbClr val="D9E2EC"/>
+                      </a:solidFill>
+                      <a:prstDash val="solid"/>
+                      <a:round/>
+                      <a:headEnd type="none" w="med" len="med"/>
+                      <a:tailEnd type="none" w="med" len="med"/>
+                    </a:lnL>
+                    <a:lnR w="6350" cap="flat" cmpd="sng" algn="ctr">
+                      <a:solidFill>
+                        <a:srgbClr val="D9E2EC"/>
+                      </a:solidFill>
+                      <a:prstDash val="solid"/>
+                      <a:round/>
+                      <a:headEnd type="none" w="med" len="med"/>
+                      <a:tailEnd type="none" w="med" len="med"/>
+                    </a:lnR>
+                    <a:lnT w="6350" cap="flat" cmpd="sng" algn="ctr">
+                      <a:solidFill>
+                        <a:srgbClr val="D9E2EC"/>
+                      </a:solidFill>
+                      <a:prstDash val="solid"/>
+                      <a:round/>
+                      <a:headEnd type="none" w="med" len="med"/>
+                      <a:tailEnd type="none" w="med" len="med"/>
+                    </a:lnT>
+                    <a:lnB w="6350" cap="flat" cmpd="sng" algn="ctr">
+                      <a:solidFill>
+                        <a:srgbClr val="D9E2EC"/>
+                      </a:solidFill>
+                      <a:prstDash val="solid"/>
+                      <a:round/>
+                      <a:headEnd type="none" w="med" len="med"/>
+                      <a:tailEnd type="none" w="med" len="med"/>
+                    </a:lnB>
+                    <a:solidFill>
+                      <a:srgbClr val="E7F0E9"/>
+                    </a:solidFill>
+                  </a:tcPr>
+                </a:tc>
+                <a:tc>
+                  <a:txBody>
+                    <a:bodyPr/>
+                    <a:lstStyle/>
+                    <a:p>
+                      <a:pPr algn="ctr" indent="0" marL="0">
+                        <a:buNone/>
+                      </a:pPr>
+                      <a:r>
+                        <a:rPr lang="en-US" sz="1100" dirty="0">
+                          <a:solidFill>
+                            <a:srgbClr val="33475B"/>
+                          </a:solidFill>
+                        </a:rPr>
+                        <a:t>0.826</a:t>
+                      </a:r>
+                      <a:endParaRPr lang="en-US" sz="1100" dirty="0"/>
+                    </a:p>
+                  </a:txBody>
+                  <a:tcPr marL="91440" marR="91440" marT="45720" marB="45720" anchor="ctr">
+                    <a:lnL w="6350" cap="flat" cmpd="sng" algn="ctr">
+                      <a:solidFill>
+                        <a:srgbClr val="D9E2EC"/>
+                      </a:solidFill>
+                      <a:prstDash val="solid"/>
+                      <a:round/>
+                      <a:headEnd type="none" w="med" len="med"/>
+                      <a:tailEnd type="none" w="med" len="med"/>
+                    </a:lnL>
+                    <a:lnR w="6350" cap="flat" cmpd="sng" algn="ctr">
+                      <a:solidFill>
+                        <a:srgbClr val="D9E2EC"/>
+                      </a:solidFill>
+                      <a:prstDash val="solid"/>
+                      <a:round/>
+                      <a:headEnd type="none" w="med" len="med"/>
+                      <a:tailEnd type="none" w="med" len="med"/>
+                    </a:lnR>
+                    <a:lnT w="6350" cap="flat" cmpd="sng" algn="ctr">
+                      <a:solidFill>
+                        <a:srgbClr val="D9E2EC"/>
+                      </a:solidFill>
+                      <a:prstDash val="solid"/>
+                      <a:round/>
+                      <a:headEnd type="none" w="med" len="med"/>
+                      <a:tailEnd type="none" w="med" len="med"/>
+                    </a:lnT>
+                    <a:lnB w="6350" cap="flat" cmpd="sng" algn="ctr">
+                      <a:solidFill>
+                        <a:srgbClr val="D9E2EC"/>
+                      </a:solidFill>
+                      <a:prstDash val="solid"/>
+                      <a:round/>
+                      <a:headEnd type="none" w="med" len="med"/>
+                      <a:tailEnd type="none" w="med" len="med"/>
+                    </a:lnB>
+                    <a:solidFill>
+                      <a:srgbClr val="E7F0E9"/>
+                    </a:solidFill>
+                  </a:tcPr>
+                </a:tc>
+                <a:tc>
+                  <a:txBody>
+                    <a:bodyPr/>
+                    <a:lstStyle/>
+                    <a:p>
+                      <a:pPr algn="ctr" indent="0" marL="0">
+                        <a:buNone/>
+                      </a:pPr>
+                      <a:r>
+                        <a:rPr lang="en-US" sz="1100" b="1" dirty="0">
+                          <a:solidFill>
+                            <a:srgbClr val="2E7D5B"/>
+                          </a:solidFill>
+                        </a:rPr>
+                        <a:t>0.961</a:t>
+                      </a:r>
+                      <a:endParaRPr lang="en-US" sz="1100" dirty="0"/>
+                    </a:p>
+                  </a:txBody>
+                  <a:tcPr marL="91440" marR="91440" marT="45720" marB="45720" anchor="ctr">
+                    <a:lnL w="6350" cap="flat" cmpd="sng" algn="ctr">
+                      <a:solidFill>
+                        <a:srgbClr val="D9E2EC"/>
+                      </a:solidFill>
+                      <a:prstDash val="solid"/>
+                      <a:round/>
+                      <a:headEnd type="none" w="med" len="med"/>
+                      <a:tailEnd type="none" w="med" len="med"/>
+                    </a:lnL>
+                    <a:lnR w="6350" cap="flat" cmpd="sng" algn="ctr">
+                      <a:solidFill>
+                        <a:srgbClr val="D9E2EC"/>
+                      </a:solidFill>
+                      <a:prstDash val="solid"/>
+                      <a:round/>
+                      <a:headEnd type="none" w="med" len="med"/>
+                      <a:tailEnd type="none" w="med" len="med"/>
+                    </a:lnR>
+                    <a:lnT w="6350" cap="flat" cmpd="sng" algn="ctr">
+                      <a:solidFill>
+                        <a:srgbClr val="D9E2EC"/>
+                      </a:solidFill>
+                      <a:prstDash val="solid"/>
+                      <a:round/>
+                      <a:headEnd type="none" w="med" len="med"/>
+                      <a:tailEnd type="none" w="med" len="med"/>
+                    </a:lnT>
+                    <a:lnB w="6350" cap="flat" cmpd="sng" algn="ctr">
+                      <a:solidFill>
+                        <a:srgbClr val="D9E2EC"/>
+                      </a:solidFill>
+                      <a:prstDash val="solid"/>
+                      <a:round/>
+                      <a:headEnd type="none" w="med" len="med"/>
+                      <a:tailEnd type="none" w="med" len="med"/>
+                    </a:lnB>
+                    <a:solidFill>
+                      <a:srgbClr val="E7F0E9"/>
+                    </a:solidFill>
+                  </a:tcPr>
+                </a:tc>
+                <a:tc>
+                  <a:txBody>
+                    <a:bodyPr/>
+                    <a:lstStyle/>
+                    <a:p>
+                      <a:pPr algn="l" indent="0" marL="0">
+                        <a:buNone/>
+                      </a:pPr>
+                      <a:r>
+                        <a:rPr lang="en-US" sz="1100" dirty="0">
+                          <a:solidFill>
+                            <a:srgbClr val="33475B"/>
+                          </a:solidFill>
+                        </a:rPr>
+                        <a:t>baseline</a:t>
+                      </a:r>
+                      <a:endParaRPr lang="en-US" sz="1100" dirty="0"/>
+                    </a:p>
+                  </a:txBody>
+                  <a:tcPr marL="91440" marR="91440" marT="45720" marB="45720" anchor="ctr">
+                    <a:lnL w="6350" cap="flat" cmpd="sng" algn="ctr">
+                      <a:solidFill>
+                        <a:srgbClr val="D9E2EC"/>
+                      </a:solidFill>
+                      <a:prstDash val="solid"/>
+                      <a:round/>
+                      <a:headEnd type="none" w="med" len="med"/>
+                      <a:tailEnd type="none" w="med" len="med"/>
+                    </a:lnL>
+                    <a:lnR w="6350" cap="flat" cmpd="sng" algn="ctr">
+                      <a:solidFill>
+                        <a:srgbClr val="D9E2EC"/>
+                      </a:solidFill>
+                      <a:prstDash val="solid"/>
+                      <a:round/>
+                      <a:headEnd type="none" w="med" len="med"/>
+                      <a:tailEnd type="none" w="med" len="med"/>
+                    </a:lnR>
+                    <a:lnT w="6350" cap="flat" cmpd="sng" algn="ctr">
+                      <a:solidFill>
+                        <a:srgbClr val="D9E2EC"/>
+                      </a:solidFill>
+                      <a:prstDash val="solid"/>
+                      <a:round/>
+                      <a:headEnd type="none" w="med" len="med"/>
+                      <a:tailEnd type="none" w="med" len="med"/>
+                    </a:lnT>
+                    <a:lnB w="6350" cap="flat" cmpd="sng" algn="ctr">
+                      <a:solidFill>
+                        <a:srgbClr val="D9E2EC"/>
+                      </a:solidFill>
+                      <a:prstDash val="solid"/>
+                      <a:round/>
+                      <a:headEnd type="none" w="med" len="med"/>
+                      <a:tailEnd type="none" w="med" len="med"/>
+                    </a:lnB>
+                    <a:solidFill>
+                      <a:srgbClr val="E7F0E9"/>
+                    </a:solidFill>
+                  </a:tcPr>
+                </a:tc>
+              </a:tr>
+              <a:tr h="475488">
+                <a:tc>
+                  <a:txBody>
+                    <a:bodyPr/>
+                    <a:lstStyle/>
+                    <a:p>
+                      <a:pPr algn="l" indent="0" marL="0">
+                        <a:buNone/>
+                      </a:pPr>
+                      <a:r>
+                        <a:rPr lang="en-US" sz="1100" dirty="0">
+                          <a:solidFill>
+                            <a:srgbClr val="33475B"/>
+                          </a:solidFill>
+                        </a:rPr>
+                        <a:t>+ Hyperparameter search (+ KNN)</a:t>
+                      </a:r>
+                      <a:endParaRPr lang="en-US" sz="1100" dirty="0"/>
+                    </a:p>
+                  </a:txBody>
+                  <a:tcPr marL="91440" marR="91440" marT="45720" marB="45720" anchor="ctr">
+                    <a:lnL w="6350" cap="flat" cmpd="sng" algn="ctr">
+                      <a:solidFill>
+                        <a:srgbClr val="D9E2EC"/>
+                      </a:solidFill>
+                      <a:prstDash val="solid"/>
+                      <a:round/>
+                      <a:headEnd type="none" w="med" len="med"/>
+                      <a:tailEnd type="none" w="med" len="med"/>
+                    </a:lnL>
+                    <a:lnR w="6350" cap="flat" cmpd="sng" algn="ctr">
+                      <a:solidFill>
+                        <a:srgbClr val="D9E2EC"/>
+                      </a:solidFill>
+                      <a:prstDash val="solid"/>
+                      <a:round/>
+                      <a:headEnd type="none" w="med" len="med"/>
+                      <a:tailEnd type="none" w="med" len="med"/>
+                    </a:lnR>
+                    <a:lnT w="6350" cap="flat" cmpd="sng" algn="ctr">
+                      <a:solidFill>
+                        <a:srgbClr val="D9E2EC"/>
+                      </a:solidFill>
+                      <a:prstDash val="solid"/>
+                      <a:round/>
+                      <a:headEnd type="none" w="med" len="med"/>
+                      <a:tailEnd type="none" w="med" len="med"/>
+                    </a:lnT>
+                    <a:lnB w="6350" cap="flat" cmpd="sng" algn="ctr">
+                      <a:solidFill>
+                        <a:srgbClr val="D9E2EC"/>
+                      </a:solidFill>
+                      <a:prstDash val="solid"/>
+                      <a:round/>
+                      <a:headEnd type="none" w="med" len="med"/>
+                      <a:tailEnd type="none" w="med" len="med"/>
+                    </a:lnB>
+                  </a:tcPr>
+                </a:tc>
+                <a:tc>
+                  <a:txBody>
+                    <a:bodyPr/>
+                    <a:lstStyle/>
+                    <a:p>
+                      <a:pPr algn="ctr" indent="0" marL="0">
+                        <a:buNone/>
+                      </a:pPr>
+                      <a:r>
+                        <a:rPr lang="en-US" sz="1100" dirty="0">
+                          <a:solidFill>
+                            <a:srgbClr val="33475B"/>
+                          </a:solidFill>
+                        </a:rPr>
+                        <a:t>0.882</a:t>
+                      </a:r>
+                      <a:endParaRPr lang="en-US" sz="1100" dirty="0"/>
+                    </a:p>
+                  </a:txBody>
+                  <a:tcPr marL="91440" marR="91440" marT="45720" marB="45720" anchor="ctr">
+                    <a:lnL w="6350" cap="flat" cmpd="sng" algn="ctr">
+                      <a:solidFill>
+                        <a:srgbClr val="D9E2EC"/>
+                      </a:solidFill>
+                      <a:prstDash val="solid"/>
+                      <a:round/>
+                      <a:headEnd type="none" w="med" len="med"/>
+                      <a:tailEnd type="none" w="med" len="med"/>
+                    </a:lnL>
+                    <a:lnR w="6350" cap="flat" cmpd="sng" algn="ctr">
+                      <a:solidFill>
+                        <a:srgbClr val="D9E2EC"/>
+                      </a:solidFill>
+                      <a:prstDash val="solid"/>
+                      <a:round/>
+                      <a:headEnd type="none" w="med" len="med"/>
+                      <a:tailEnd type="none" w="med" len="med"/>
+                    </a:lnR>
+                    <a:lnT w="6350" cap="flat" cmpd="sng" algn="ctr">
+                      <a:solidFill>
+                        <a:srgbClr val="D9E2EC"/>
+                      </a:solidFill>
+                      <a:prstDash val="solid"/>
+                      <a:round/>
+                      <a:headEnd type="none" w="med" len="med"/>
+                      <a:tailEnd type="none" w="med" len="med"/>
+                    </a:lnT>
+                    <a:lnB w="6350" cap="flat" cmpd="sng" algn="ctr">
+                      <a:solidFill>
+                        <a:srgbClr val="D9E2EC"/>
+                      </a:solidFill>
+                      <a:prstDash val="solid"/>
+                      <a:round/>
+                      <a:headEnd type="none" w="med" len="med"/>
+                      <a:tailEnd type="none" w="med" len="med"/>
+                    </a:lnB>
+                  </a:tcPr>
+                </a:tc>
+                <a:tc>
+                  <a:txBody>
+                    <a:bodyPr/>
+                    <a:lstStyle/>
+                    <a:p>
+                      <a:pPr algn="ctr" indent="0" marL="0">
+                        <a:buNone/>
+                      </a:pPr>
+                      <a:r>
+                        <a:rPr lang="en-US" sz="1100" dirty="0">
+                          <a:solidFill>
+                            <a:srgbClr val="33475B"/>
+                          </a:solidFill>
+                        </a:rPr>
+                        <a:t>0.910</a:t>
+                      </a:r>
+                      <a:endParaRPr lang="en-US" sz="1100" dirty="0"/>
+                    </a:p>
+                  </a:txBody>
+                  <a:tcPr marL="91440" marR="91440" marT="45720" marB="45720" anchor="ctr">
+                    <a:lnL w="6350" cap="flat" cmpd="sng" algn="ctr">
+                      <a:solidFill>
+                        <a:srgbClr val="D9E2EC"/>
+                      </a:solidFill>
+                      <a:prstDash val="solid"/>
+                      <a:round/>
+                      <a:headEnd type="none" w="med" len="med"/>
+                      <a:tailEnd type="none" w="med" len="med"/>
+                    </a:lnL>
+                    <a:lnR w="6350" cap="flat" cmpd="sng" algn="ctr">
+                      <a:solidFill>
+                        <a:srgbClr val="D9E2EC"/>
+                      </a:solidFill>
+                      <a:prstDash val="solid"/>
+                      <a:round/>
+                      <a:headEnd type="none" w="med" len="med"/>
+                      <a:tailEnd type="none" w="med" len="med"/>
+                    </a:lnR>
+                    <a:lnT w="6350" cap="flat" cmpd="sng" algn="ctr">
+                      <a:solidFill>
+                        <a:srgbClr val="D9E2EC"/>
+                      </a:solidFill>
+                      <a:prstDash val="solid"/>
+                      <a:round/>
+                      <a:headEnd type="none" w="med" len="med"/>
+                      <a:tailEnd type="none" w="med" len="med"/>
+                    </a:lnT>
+                    <a:lnB w="6350" cap="flat" cmpd="sng" algn="ctr">
+                      <a:solidFill>
+                        <a:srgbClr val="D9E2EC"/>
+                      </a:solidFill>
+                      <a:prstDash val="solid"/>
+                      <a:round/>
+                      <a:headEnd type="none" w="med" len="med"/>
+                      <a:tailEnd type="none" w="med" len="med"/>
+                    </a:lnB>
+                  </a:tcPr>
+                </a:tc>
+                <a:tc>
+                  <a:txBody>
+                    <a:bodyPr/>
+                    <a:lstStyle/>
+                    <a:p>
+                      <a:pPr algn="ctr" indent="0" marL="0">
+                        <a:buNone/>
+                      </a:pPr>
+                      <a:r>
+                        <a:rPr lang="en-US" sz="1100" dirty="0">
+                          <a:solidFill>
+                            <a:srgbClr val="33475B"/>
+                          </a:solidFill>
+                        </a:rPr>
+                        <a:t>0.815</a:t>
+                      </a:r>
+                      <a:endParaRPr lang="en-US" sz="1100" dirty="0"/>
+                    </a:p>
+                  </a:txBody>
+                  <a:tcPr marL="91440" marR="91440" marT="45720" marB="45720" anchor="ctr">
+                    <a:lnL w="6350" cap="flat" cmpd="sng" algn="ctr">
+                      <a:solidFill>
+                        <a:srgbClr val="D9E2EC"/>
+                      </a:solidFill>
+                      <a:prstDash val="solid"/>
+                      <a:round/>
+                      <a:headEnd type="none" w="med" len="med"/>
+                      <a:tailEnd type="none" w="med" len="med"/>
+                    </a:lnL>
+                    <a:lnR w="6350" cap="flat" cmpd="sng" algn="ctr">
+                      <a:solidFill>
+                        <a:srgbClr val="D9E2EC"/>
+                      </a:solidFill>
+                      <a:prstDash val="solid"/>
+                      <a:round/>
+                      <a:headEnd type="none" w="med" len="med"/>
+                      <a:tailEnd type="none" w="med" len="med"/>
+                    </a:lnR>
+                    <a:lnT w="6350" cap="flat" cmpd="sng" algn="ctr">
+                      <a:solidFill>
+                        <a:srgbClr val="D9E2EC"/>
+                      </a:solidFill>
+                      <a:prstDash val="solid"/>
+                      <a:round/>
+                      <a:headEnd type="none" w="med" len="med"/>
+                      <a:tailEnd type="none" w="med" len="med"/>
+                    </a:lnT>
+                    <a:lnB w="6350" cap="flat" cmpd="sng" algn="ctr">
+                      <a:solidFill>
+                        <a:srgbClr val="D9E2EC"/>
+                      </a:solidFill>
+                      <a:prstDash val="solid"/>
+                      <a:round/>
+                      <a:headEnd type="none" w="med" len="med"/>
+                      <a:tailEnd type="none" w="med" len="med"/>
+                    </a:lnB>
+                  </a:tcPr>
+                </a:tc>
+                <a:tc>
+                  <a:txBody>
+                    <a:bodyPr/>
+                    <a:lstStyle/>
+                    <a:p>
+                      <a:pPr algn="ctr" indent="0" marL="0">
+                        <a:buNone/>
+                      </a:pPr>
+                      <a:r>
+                        <a:rPr lang="en-US" sz="1100" dirty="0">
+                          <a:solidFill>
+                            <a:srgbClr val="33475B"/>
+                          </a:solidFill>
+                        </a:rPr>
+                        <a:t>0.961</a:t>
+                      </a:r>
+                      <a:endParaRPr lang="en-US" sz="1100" dirty="0"/>
+                    </a:p>
+                  </a:txBody>
+                  <a:tcPr marL="91440" marR="91440" marT="45720" marB="45720" anchor="ctr">
+                    <a:lnL w="6350" cap="flat" cmpd="sng" algn="ctr">
+                      <a:solidFill>
+                        <a:srgbClr val="D9E2EC"/>
+                      </a:solidFill>
+                      <a:prstDash val="solid"/>
+                      <a:round/>
+                      <a:headEnd type="none" w="med" len="med"/>
+                      <a:tailEnd type="none" w="med" len="med"/>
+                    </a:lnL>
+                    <a:lnR w="6350" cap="flat" cmpd="sng" algn="ctr">
+                      <a:solidFill>
+                        <a:srgbClr val="D9E2EC"/>
+                      </a:solidFill>
+                      <a:prstDash val="solid"/>
+                      <a:round/>
+                      <a:headEnd type="none" w="med" len="med"/>
+                      <a:tailEnd type="none" w="med" len="med"/>
+                    </a:lnR>
+                    <a:lnT w="6350" cap="flat" cmpd="sng" algn="ctr">
+                      <a:solidFill>
+                        <a:srgbClr val="D9E2EC"/>
+                      </a:solidFill>
+                      <a:prstDash val="solid"/>
+                      <a:round/>
+                      <a:headEnd type="none" w="med" len="med"/>
+                      <a:tailEnd type="none" w="med" len="med"/>
+                    </a:lnT>
+                    <a:lnB w="6350" cap="flat" cmpd="sng" algn="ctr">
+                      <a:solidFill>
+                        <a:srgbClr val="D9E2EC"/>
+                      </a:solidFill>
+                      <a:prstDash val="solid"/>
+                      <a:round/>
+                      <a:headEnd type="none" w="med" len="med"/>
+                      <a:tailEnd type="none" w="med" len="med"/>
+                    </a:lnB>
+                  </a:tcPr>
+                </a:tc>
+                <a:tc>
+                  <a:txBody>
+                    <a:bodyPr/>
+                    <a:lstStyle/>
+                    <a:p>
+                      <a:pPr algn="l" indent="0" marL="0">
+                        <a:buNone/>
+                      </a:pPr>
+                      <a:r>
+                        <a:rPr lang="en-US" sz="1100" dirty="0">
+                          <a:solidFill>
+                            <a:srgbClr val="70819A"/>
+                          </a:solidFill>
+                        </a:rPr>
+                        <a:t>AUC ↑ = noise</a:t>
+                      </a:r>
+                      <a:endParaRPr lang="en-US" sz="1100" dirty="0"/>
+                    </a:p>
+                  </a:txBody>
+                  <a:tcPr marL="91440" marR="91440" marT="45720" marB="45720" anchor="ctr">
+                    <a:lnL w="6350" cap="flat" cmpd="sng" algn="ctr">
+                      <a:solidFill>
+                        <a:srgbClr val="D9E2EC"/>
+                      </a:solidFill>
+                      <a:prstDash val="solid"/>
+                      <a:round/>
+                      <a:headEnd type="none" w="med" len="med"/>
+                      <a:tailEnd type="none" w="med" len="med"/>
+                    </a:lnL>
+                    <a:lnR w="6350" cap="flat" cmpd="sng" algn="ctr">
+                      <a:solidFill>
+                        <a:srgbClr val="D9E2EC"/>
+                      </a:solidFill>
+                      <a:prstDash val="solid"/>
+                      <a:round/>
+                      <a:headEnd type="none" w="med" len="med"/>
+                      <a:tailEnd type="none" w="med" len="med"/>
+                    </a:lnR>
+                    <a:lnT w="6350" cap="flat" cmpd="sng" algn="ctr">
+                      <a:solidFill>
+                        <a:srgbClr val="D9E2EC"/>
+                      </a:solidFill>
+                      <a:prstDash val="solid"/>
+                      <a:round/>
+                      <a:headEnd type="none" w="med" len="med"/>
+                      <a:tailEnd type="none" w="med" len="med"/>
+                    </a:lnT>
+                    <a:lnB w="6350" cap="flat" cmpd="sng" algn="ctr">
+                      <a:solidFill>
+                        <a:srgbClr val="D9E2EC"/>
+                      </a:solidFill>
+                      <a:prstDash val="solid"/>
+                      <a:round/>
+                      <a:headEnd type="none" w="med" len="med"/>
+                      <a:tailEnd type="none" w="med" len="med"/>
+                    </a:lnB>
+                  </a:tcPr>
+                </a:tc>
+              </a:tr>
+              <a:tr h="475488">
+                <a:tc>
+                  <a:txBody>
+                    <a:bodyPr/>
+                    <a:lstStyle/>
+                    <a:p>
+                      <a:pPr algn="l" indent="0" marL="0">
+                        <a:buNone/>
+                      </a:pPr>
+                      <a:r>
+                        <a:rPr lang="en-US" sz="1100" dirty="0">
+                          <a:solidFill>
+                            <a:srgbClr val="33475B"/>
+                          </a:solidFill>
+                        </a:rPr>
+                        <a:t>+ Feature engineering</a:t>
+                      </a:r>
+                      <a:endParaRPr lang="en-US" sz="1100" dirty="0"/>
+                    </a:p>
+                  </a:txBody>
+                  <a:tcPr marL="91440" marR="91440" marT="45720" marB="45720" anchor="ctr">
+                    <a:lnL w="6350" cap="flat" cmpd="sng" algn="ctr">
+                      <a:solidFill>
+                        <a:srgbClr val="D9E2EC"/>
+                      </a:solidFill>
+                      <a:prstDash val="solid"/>
+                      <a:round/>
+                      <a:headEnd type="none" w="med" len="med"/>
+                      <a:tailEnd type="none" w="med" len="med"/>
+                    </a:lnL>
+                    <a:lnR w="6350" cap="flat" cmpd="sng" algn="ctr">
+                      <a:solidFill>
+                        <a:srgbClr val="D9E2EC"/>
+                      </a:solidFill>
+                      <a:prstDash val="solid"/>
+                      <a:round/>
+                      <a:headEnd type="none" w="med" len="med"/>
+                      <a:tailEnd type="none" w="med" len="med"/>
+                    </a:lnR>
+                    <a:lnT w="6350" cap="flat" cmpd="sng" algn="ctr">
+                      <a:solidFill>
+                        <a:srgbClr val="D9E2EC"/>
+                      </a:solidFill>
+                      <a:prstDash val="solid"/>
+                      <a:round/>
+                      <a:headEnd type="none" w="med" len="med"/>
+                      <a:tailEnd type="none" w="med" len="med"/>
+                    </a:lnT>
+                    <a:lnB w="6350" cap="flat" cmpd="sng" algn="ctr">
+                      <a:solidFill>
+                        <a:srgbClr val="D9E2EC"/>
+                      </a:solidFill>
+                      <a:prstDash val="solid"/>
+                      <a:round/>
+                      <a:headEnd type="none" w="med" len="med"/>
+                      <a:tailEnd type="none" w="med" len="med"/>
+                    </a:lnB>
+                  </a:tcPr>
+                </a:tc>
+                <a:tc>
+                  <a:txBody>
+                    <a:bodyPr/>
+                    <a:lstStyle/>
+                    <a:p>
+                      <a:pPr algn="ctr" indent="0" marL="0">
+                        <a:buNone/>
+                      </a:pPr>
+                      <a:r>
+                        <a:rPr lang="en-US" sz="1100" dirty="0">
+                          <a:solidFill>
+                            <a:srgbClr val="33475B"/>
+                          </a:solidFill>
+                        </a:rPr>
+                        <a:t>0.876</a:t>
+                      </a:r>
+                      <a:endParaRPr lang="en-US" sz="1100" dirty="0"/>
+                    </a:p>
+                  </a:txBody>
+                  <a:tcPr marL="91440" marR="91440" marT="45720" marB="45720" anchor="ctr">
+                    <a:lnL w="6350" cap="flat" cmpd="sng" algn="ctr">
+                      <a:solidFill>
+                        <a:srgbClr val="D9E2EC"/>
+                      </a:solidFill>
+                      <a:prstDash val="solid"/>
+                      <a:round/>
+                      <a:headEnd type="none" w="med" len="med"/>
+                      <a:tailEnd type="none" w="med" len="med"/>
+                    </a:lnL>
+                    <a:lnR w="6350" cap="flat" cmpd="sng" algn="ctr">
+                      <a:solidFill>
+                        <a:srgbClr val="D9E2EC"/>
+                      </a:solidFill>
+                      <a:prstDash val="solid"/>
+                      <a:round/>
+                      <a:headEnd type="none" w="med" len="med"/>
+                      <a:tailEnd type="none" w="med" len="med"/>
+                    </a:lnR>
+                    <a:lnT w="6350" cap="flat" cmpd="sng" algn="ctr">
+                      <a:solidFill>
+                        <a:srgbClr val="D9E2EC"/>
+                      </a:solidFill>
+                      <a:prstDash val="solid"/>
+                      <a:round/>
+                      <a:headEnd type="none" w="med" len="med"/>
+                      <a:tailEnd type="none" w="med" len="med"/>
+                    </a:lnT>
+                    <a:lnB w="6350" cap="flat" cmpd="sng" algn="ctr">
+                      <a:solidFill>
+                        <a:srgbClr val="D9E2EC"/>
+                      </a:solidFill>
+                      <a:prstDash val="solid"/>
+                      <a:round/>
+                      <a:headEnd type="none" w="med" len="med"/>
+                      <a:tailEnd type="none" w="med" len="med"/>
+                    </a:lnB>
+                  </a:tcPr>
+                </a:tc>
+                <a:tc>
+                  <a:txBody>
+                    <a:bodyPr/>
+                    <a:lstStyle/>
+                    <a:p>
+                      <a:pPr algn="ctr" indent="0" marL="0">
+                        <a:buNone/>
+                      </a:pPr>
+                      <a:r>
+                        <a:rPr lang="en-US" sz="1100" dirty="0">
+                          <a:solidFill>
+                            <a:srgbClr val="33475B"/>
+                          </a:solidFill>
+                        </a:rPr>
+                        <a:t>0.913</a:t>
+                      </a:r>
+                      <a:endParaRPr lang="en-US" sz="1100" dirty="0"/>
+                    </a:p>
+                  </a:txBody>
+                  <a:tcPr marL="91440" marR="91440" marT="45720" marB="45720" anchor="ctr">
+                    <a:lnL w="6350" cap="flat" cmpd="sng" algn="ctr">
+                      <a:solidFill>
+                        <a:srgbClr val="D9E2EC"/>
+                      </a:solidFill>
+                      <a:prstDash val="solid"/>
+                      <a:round/>
+                      <a:headEnd type="none" w="med" len="med"/>
+                      <a:tailEnd type="none" w="med" len="med"/>
+                    </a:lnL>
+                    <a:lnR w="6350" cap="flat" cmpd="sng" algn="ctr">
+                      <a:solidFill>
+                        <a:srgbClr val="D9E2EC"/>
+                      </a:solidFill>
+                      <a:prstDash val="solid"/>
+                      <a:round/>
+                      <a:headEnd type="none" w="med" len="med"/>
+                      <a:tailEnd type="none" w="med" len="med"/>
+                    </a:lnR>
+                    <a:lnT w="6350" cap="flat" cmpd="sng" algn="ctr">
+                      <a:solidFill>
+                        <a:srgbClr val="D9E2EC"/>
+                      </a:solidFill>
+                      <a:prstDash val="solid"/>
+                      <a:round/>
+                      <a:headEnd type="none" w="med" len="med"/>
+                      <a:tailEnd type="none" w="med" len="med"/>
+                    </a:lnT>
+                    <a:lnB w="6350" cap="flat" cmpd="sng" algn="ctr">
+                      <a:solidFill>
+                        <a:srgbClr val="D9E2EC"/>
+                      </a:solidFill>
+                      <a:prstDash val="solid"/>
+                      <a:round/>
+                      <a:headEnd type="none" w="med" len="med"/>
+                      <a:tailEnd type="none" w="med" len="med"/>
+                    </a:lnB>
+                  </a:tcPr>
+                </a:tc>
+                <a:tc>
+                  <a:txBody>
+                    <a:bodyPr/>
+                    <a:lstStyle/>
+                    <a:p>
+                      <a:pPr algn="ctr" indent="0" marL="0">
+                        <a:buNone/>
+                      </a:pPr>
+                      <a:r>
+                        <a:rPr lang="en-US" sz="1100" b="1" dirty="0">
+                          <a:solidFill>
+                            <a:srgbClr val="1C7293"/>
+                          </a:solidFill>
+                        </a:rPr>
+                        <a:t>0.837</a:t>
+                      </a:r>
+                      <a:endParaRPr lang="en-US" sz="1100" dirty="0"/>
+                    </a:p>
+                  </a:txBody>
+                  <a:tcPr marL="91440" marR="91440" marT="45720" marB="45720" anchor="ctr">
+                    <a:lnL w="6350" cap="flat" cmpd="sng" algn="ctr">
+                      <a:solidFill>
+                        <a:srgbClr val="D9E2EC"/>
+                      </a:solidFill>
+                      <a:prstDash val="solid"/>
+                      <a:round/>
+                      <a:headEnd type="none" w="med" len="med"/>
+                      <a:tailEnd type="none" w="med" len="med"/>
+                    </a:lnL>
+                    <a:lnR w="6350" cap="flat" cmpd="sng" algn="ctr">
+                      <a:solidFill>
+                        <a:srgbClr val="D9E2EC"/>
+                      </a:solidFill>
+                      <a:prstDash val="solid"/>
+                      <a:round/>
+                      <a:headEnd type="none" w="med" len="med"/>
+                      <a:tailEnd type="none" w="med" len="med"/>
+                    </a:lnR>
+                    <a:lnT w="6350" cap="flat" cmpd="sng" algn="ctr">
+                      <a:solidFill>
+                        <a:srgbClr val="D9E2EC"/>
+                      </a:solidFill>
+                      <a:prstDash val="solid"/>
+                      <a:round/>
+                      <a:headEnd type="none" w="med" len="med"/>
+                      <a:tailEnd type="none" w="med" len="med"/>
+                    </a:lnT>
+                    <a:lnB w="6350" cap="flat" cmpd="sng" algn="ctr">
+                      <a:solidFill>
+                        <a:srgbClr val="D9E2EC"/>
+                      </a:solidFill>
+                      <a:prstDash val="solid"/>
+                      <a:round/>
+                      <a:headEnd type="none" w="med" len="med"/>
+                      <a:tailEnd type="none" w="med" len="med"/>
+                    </a:lnB>
+                  </a:tcPr>
+                </a:tc>
+                <a:tc>
+                  <a:txBody>
+                    <a:bodyPr/>
+                    <a:lstStyle/>
+                    <a:p>
+                      <a:pPr algn="ctr" indent="0" marL="0">
+                        <a:buNone/>
+                      </a:pPr>
+                      <a:r>
+                        <a:rPr lang="en-US" sz="1100" dirty="0">
+                          <a:solidFill>
+                            <a:srgbClr val="33475B"/>
+                          </a:solidFill>
+                        </a:rPr>
+                        <a:t>0.961</a:t>
+                      </a:r>
+                      <a:endParaRPr lang="en-US" sz="1100" dirty="0"/>
+                    </a:p>
+                  </a:txBody>
+                  <a:tcPr marL="91440" marR="91440" marT="45720" marB="45720" anchor="ctr">
+                    <a:lnL w="6350" cap="flat" cmpd="sng" algn="ctr">
+                      <a:solidFill>
+                        <a:srgbClr val="D9E2EC"/>
+                      </a:solidFill>
+                      <a:prstDash val="solid"/>
+                      <a:round/>
+                      <a:headEnd type="none" w="med" len="med"/>
+                      <a:tailEnd type="none" w="med" len="med"/>
+                    </a:lnL>
+                    <a:lnR w="6350" cap="flat" cmpd="sng" algn="ctr">
+                      <a:solidFill>
+                        <a:srgbClr val="D9E2EC"/>
+                      </a:solidFill>
+                      <a:prstDash val="solid"/>
+                      <a:round/>
+                      <a:headEnd type="none" w="med" len="med"/>
+                      <a:tailEnd type="none" w="med" len="med"/>
+                    </a:lnR>
+                    <a:lnT w="6350" cap="flat" cmpd="sng" algn="ctr">
+                      <a:solidFill>
+                        <a:srgbClr val="D9E2EC"/>
+                      </a:solidFill>
+                      <a:prstDash val="solid"/>
+                      <a:round/>
+                      <a:headEnd type="none" w="med" len="med"/>
+                      <a:tailEnd type="none" w="med" len="med"/>
+                    </a:lnT>
+                    <a:lnB w="6350" cap="flat" cmpd="sng" algn="ctr">
+                      <a:solidFill>
+                        <a:srgbClr val="D9E2EC"/>
+                      </a:solidFill>
+                      <a:prstDash val="solid"/>
+                      <a:round/>
+                      <a:headEnd type="none" w="med" len="med"/>
+                      <a:tailEnd type="none" w="med" len="med"/>
+                    </a:lnB>
+                  </a:tcPr>
+                </a:tc>
+                <a:tc>
+                  <a:txBody>
+                    <a:bodyPr/>
+                    <a:lstStyle/>
+                    <a:p>
+                      <a:pPr algn="l" indent="0" marL="0">
+                        <a:buNone/>
+                      </a:pPr>
+                      <a:r>
+                        <a:rPr lang="en-US" sz="1100" dirty="0">
+                          <a:solidFill>
+                            <a:srgbClr val="70819A"/>
+                          </a:solidFill>
+                        </a:rPr>
+                        <a:t>best test acc, CV flat</a:t>
+                      </a:r>
+                      <a:endParaRPr lang="en-US" sz="1100" dirty="0"/>
+                    </a:p>
+                  </a:txBody>
+                  <a:tcPr marL="91440" marR="91440" marT="45720" marB="45720" anchor="ctr">
+                    <a:lnL w="6350" cap="flat" cmpd="sng" algn="ctr">
+                      <a:solidFill>
+                        <a:srgbClr val="D9E2EC"/>
+                      </a:solidFill>
+                      <a:prstDash val="solid"/>
+                      <a:round/>
+                      <a:headEnd type="none" w="med" len="med"/>
+                      <a:tailEnd type="none" w="med" len="med"/>
+                    </a:lnL>
+                    <a:lnR w="6350" cap="flat" cmpd="sng" algn="ctr">
+                      <a:solidFill>
+                        <a:srgbClr val="D9E2EC"/>
+                      </a:solidFill>
+                      <a:prstDash val="solid"/>
+                      <a:round/>
+                      <a:headEnd type="none" w="med" len="med"/>
+                      <a:tailEnd type="none" w="med" len="med"/>
+                    </a:lnR>
+                    <a:lnT w="6350" cap="flat" cmpd="sng" algn="ctr">
+                      <a:solidFill>
+                        <a:srgbClr val="D9E2EC"/>
+                      </a:solidFill>
+                      <a:prstDash val="solid"/>
+                      <a:round/>
+                      <a:headEnd type="none" w="med" len="med"/>
+                      <a:tailEnd type="none" w="med" len="med"/>
+                    </a:lnT>
+                    <a:lnB w="6350" cap="flat" cmpd="sng" algn="ctr">
+                      <a:solidFill>
+                        <a:srgbClr val="D9E2EC"/>
+                      </a:solidFill>
+                      <a:prstDash val="solid"/>
+                      <a:round/>
+                      <a:headEnd type="none" w="med" len="med"/>
+                      <a:tailEnd type="none" w="med" len="med"/>
+                    </a:lnB>
+                  </a:tcPr>
+                </a:tc>
+              </a:tr>
+              <a:tr h="475488">
+                <a:tc>
+                  <a:txBody>
+                    <a:bodyPr/>
+                    <a:lstStyle/>
+                    <a:p>
+                      <a:pPr algn="l" indent="0" marL="0">
+                        <a:buNone/>
+                      </a:pPr>
+                      <a:r>
+                        <a:rPr lang="en-US" sz="1100" dirty="0">
+                          <a:solidFill>
+                            <a:srgbClr val="33475B"/>
+                          </a:solidFill>
+                        </a:rPr>
+                        <a:t>+ Neural network (MLP)</a:t>
+                      </a:r>
+                      <a:endParaRPr lang="en-US" sz="1100" dirty="0"/>
+                    </a:p>
+                  </a:txBody>
+                  <a:tcPr marL="91440" marR="91440" marT="45720" marB="45720" anchor="ctr">
+                    <a:lnL w="6350" cap="flat" cmpd="sng" algn="ctr">
+                      <a:solidFill>
+                        <a:srgbClr val="D9E2EC"/>
+                      </a:solidFill>
+                      <a:prstDash val="solid"/>
+                      <a:round/>
+                      <a:headEnd type="none" w="med" len="med"/>
+                      <a:tailEnd type="none" w="med" len="med"/>
+                    </a:lnL>
+                    <a:lnR w="6350" cap="flat" cmpd="sng" algn="ctr">
+                      <a:solidFill>
+                        <a:srgbClr val="D9E2EC"/>
+                      </a:solidFill>
+                      <a:prstDash val="solid"/>
+                      <a:round/>
+                      <a:headEnd type="none" w="med" len="med"/>
+                      <a:tailEnd type="none" w="med" len="med"/>
+                    </a:lnR>
+                    <a:lnT w="6350" cap="flat" cmpd="sng" algn="ctr">
+                      <a:solidFill>
+                        <a:srgbClr val="D9E2EC"/>
+                      </a:solidFill>
+                      <a:prstDash val="solid"/>
+                      <a:round/>
+                      <a:headEnd type="none" w="med" len="med"/>
+                      <a:tailEnd type="none" w="med" len="med"/>
+                    </a:lnT>
+                    <a:lnB w="6350" cap="flat" cmpd="sng" algn="ctr">
+                      <a:solidFill>
+                        <a:srgbClr val="D9E2EC"/>
+                      </a:solidFill>
+                      <a:prstDash val="solid"/>
+                      <a:round/>
+                      <a:headEnd type="none" w="med" len="med"/>
+                      <a:tailEnd type="none" w="med" len="med"/>
+                    </a:lnB>
+                  </a:tcPr>
+                </a:tc>
+                <a:tc>
+                  <a:txBody>
+                    <a:bodyPr/>
+                    <a:lstStyle/>
+                    <a:p>
+                      <a:pPr algn="ctr" indent="0" marL="0">
+                        <a:buNone/>
+                      </a:pPr>
+                      <a:r>
+                        <a:rPr lang="en-US" sz="1100" dirty="0">
+                          <a:solidFill>
+                            <a:srgbClr val="33475B"/>
+                          </a:solidFill>
+                        </a:rPr>
+                        <a:t>0.885</a:t>
+                      </a:r>
+                      <a:endParaRPr lang="en-US" sz="1100" dirty="0"/>
+                    </a:p>
+                  </a:txBody>
+                  <a:tcPr marL="91440" marR="91440" marT="45720" marB="45720" anchor="ctr">
+                    <a:lnL w="6350" cap="flat" cmpd="sng" algn="ctr">
+                      <a:solidFill>
+                        <a:srgbClr val="D9E2EC"/>
+                      </a:solidFill>
+                      <a:prstDash val="solid"/>
+                      <a:round/>
+                      <a:headEnd type="none" w="med" len="med"/>
+                      <a:tailEnd type="none" w="med" len="med"/>
+                    </a:lnL>
+                    <a:lnR w="6350" cap="flat" cmpd="sng" algn="ctr">
+                      <a:solidFill>
+                        <a:srgbClr val="D9E2EC"/>
+                      </a:solidFill>
+                      <a:prstDash val="solid"/>
+                      <a:round/>
+                      <a:headEnd type="none" w="med" len="med"/>
+                      <a:tailEnd type="none" w="med" len="med"/>
+                    </a:lnR>
+                    <a:lnT w="6350" cap="flat" cmpd="sng" algn="ctr">
+                      <a:solidFill>
+                        <a:srgbClr val="D9E2EC"/>
+                      </a:solidFill>
+                      <a:prstDash val="solid"/>
+                      <a:round/>
+                      <a:headEnd type="none" w="med" len="med"/>
+                      <a:tailEnd type="none" w="med" len="med"/>
+                    </a:lnT>
+                    <a:lnB w="6350" cap="flat" cmpd="sng" algn="ctr">
+                      <a:solidFill>
+                        <a:srgbClr val="D9E2EC"/>
+                      </a:solidFill>
+                      <a:prstDash val="solid"/>
+                      <a:round/>
+                      <a:headEnd type="none" w="med" len="med"/>
+                      <a:tailEnd type="none" w="med" len="med"/>
+                    </a:lnB>
+                  </a:tcPr>
+                </a:tc>
+                <a:tc>
+                  <a:txBody>
+                    <a:bodyPr/>
+                    <a:lstStyle/>
+                    <a:p>
+                      <a:pPr algn="ctr" indent="0" marL="0">
+                        <a:buNone/>
+                      </a:pPr>
+                      <a:r>
+                        <a:rPr lang="en-US" sz="1100" dirty="0">
+                          <a:solidFill>
+                            <a:srgbClr val="33475B"/>
+                          </a:solidFill>
+                        </a:rPr>
+                        <a:t>0.898</a:t>
+                      </a:r>
+                      <a:endParaRPr lang="en-US" sz="1100" dirty="0"/>
+                    </a:p>
+                  </a:txBody>
+                  <a:tcPr marL="91440" marR="91440" marT="45720" marB="45720" anchor="ctr">
+                    <a:lnL w="6350" cap="flat" cmpd="sng" algn="ctr">
+                      <a:solidFill>
+                        <a:srgbClr val="D9E2EC"/>
+                      </a:solidFill>
+                      <a:prstDash val="solid"/>
+                      <a:round/>
+                      <a:headEnd type="none" w="med" len="med"/>
+                      <a:tailEnd type="none" w="med" len="med"/>
+                    </a:lnL>
+                    <a:lnR w="6350" cap="flat" cmpd="sng" algn="ctr">
+                      <a:solidFill>
+                        <a:srgbClr val="D9E2EC"/>
+                      </a:solidFill>
+                      <a:prstDash val="solid"/>
+                      <a:round/>
+                      <a:headEnd type="none" w="med" len="med"/>
+                      <a:tailEnd type="none" w="med" len="med"/>
+                    </a:lnR>
+                    <a:lnT w="6350" cap="flat" cmpd="sng" algn="ctr">
+                      <a:solidFill>
+                        <a:srgbClr val="D9E2EC"/>
+                      </a:solidFill>
+                      <a:prstDash val="solid"/>
+                      <a:round/>
+                      <a:headEnd type="none" w="med" len="med"/>
+                      <a:tailEnd type="none" w="med" len="med"/>
+                    </a:lnT>
+                    <a:lnB w="6350" cap="flat" cmpd="sng" algn="ctr">
+                      <a:solidFill>
+                        <a:srgbClr val="D9E2EC"/>
+                      </a:solidFill>
+                      <a:prstDash val="solid"/>
+                      <a:round/>
+                      <a:headEnd type="none" w="med" len="med"/>
+                      <a:tailEnd type="none" w="med" len="med"/>
+                    </a:lnB>
+                  </a:tcPr>
+                </a:tc>
+                <a:tc>
+                  <a:txBody>
+                    <a:bodyPr/>
+                    <a:lstStyle/>
+                    <a:p>
+                      <a:pPr algn="ctr" indent="0" marL="0">
+                        <a:buNone/>
+                      </a:pPr>
+                      <a:r>
+                        <a:rPr lang="en-US" sz="1100" dirty="0">
+                          <a:solidFill>
+                            <a:srgbClr val="33475B"/>
+                          </a:solidFill>
+                        </a:rPr>
+                        <a:t>0.832</a:t>
+                      </a:r>
+                      <a:endParaRPr lang="en-US" sz="1100" dirty="0"/>
+                    </a:p>
+                  </a:txBody>
+                  <a:tcPr marL="91440" marR="91440" marT="45720" marB="45720" anchor="ctr">
+                    <a:lnL w="6350" cap="flat" cmpd="sng" algn="ctr">
+                      <a:solidFill>
+                        <a:srgbClr val="D9E2EC"/>
+                      </a:solidFill>
+                      <a:prstDash val="solid"/>
+                      <a:round/>
+                      <a:headEnd type="none" w="med" len="med"/>
+                      <a:tailEnd type="none" w="med" len="med"/>
+                    </a:lnL>
+                    <a:lnR w="6350" cap="flat" cmpd="sng" algn="ctr">
+                      <a:solidFill>
+                        <a:srgbClr val="D9E2EC"/>
+                      </a:solidFill>
+                      <a:prstDash val="solid"/>
+                      <a:round/>
+                      <a:headEnd type="none" w="med" len="med"/>
+                      <a:tailEnd type="none" w="med" len="med"/>
+                    </a:lnR>
+                    <a:lnT w="6350" cap="flat" cmpd="sng" algn="ctr">
+                      <a:solidFill>
+                        <a:srgbClr val="D9E2EC"/>
+                      </a:solidFill>
+                      <a:prstDash val="solid"/>
+                      <a:round/>
+                      <a:headEnd type="none" w="med" len="med"/>
+                      <a:tailEnd type="none" w="med" len="med"/>
+                    </a:lnT>
+                    <a:lnB w="6350" cap="flat" cmpd="sng" algn="ctr">
+                      <a:solidFill>
+                        <a:srgbClr val="D9E2EC"/>
+                      </a:solidFill>
+                      <a:prstDash val="solid"/>
+                      <a:round/>
+                      <a:headEnd type="none" w="med" len="med"/>
+                      <a:tailEnd type="none" w="med" len="med"/>
+                    </a:lnB>
+                  </a:tcPr>
+                </a:tc>
+                <a:tc>
+                  <a:txBody>
+                    <a:bodyPr/>
+                    <a:lstStyle/>
+                    <a:p>
+                      <a:pPr algn="ctr" indent="0" marL="0">
+                        <a:buNone/>
+                      </a:pPr>
+                      <a:r>
+                        <a:rPr lang="en-US" sz="1100" dirty="0">
+                          <a:solidFill>
+                            <a:srgbClr val="C0392B"/>
+                          </a:solidFill>
+                        </a:rPr>
+                        <a:t>0.941</a:t>
+                      </a:r>
+                      <a:endParaRPr lang="en-US" sz="1100" dirty="0"/>
+                    </a:p>
+                  </a:txBody>
+                  <a:tcPr marL="91440" marR="91440" marT="45720" marB="45720" anchor="ctr">
+                    <a:lnL w="6350" cap="flat" cmpd="sng" algn="ctr">
+                      <a:solidFill>
+                        <a:srgbClr val="D9E2EC"/>
+                      </a:solidFill>
+                      <a:prstDash val="solid"/>
+                      <a:round/>
+                      <a:headEnd type="none" w="med" len="med"/>
+                      <a:tailEnd type="none" w="med" len="med"/>
+                    </a:lnL>
+                    <a:lnR w="6350" cap="flat" cmpd="sng" algn="ctr">
+                      <a:solidFill>
+                        <a:srgbClr val="D9E2EC"/>
+                      </a:solidFill>
+                      <a:prstDash val="solid"/>
+                      <a:round/>
+                      <a:headEnd type="none" w="med" len="med"/>
+                      <a:tailEnd type="none" w="med" len="med"/>
+                    </a:lnR>
+                    <a:lnT w="6350" cap="flat" cmpd="sng" algn="ctr">
+                      <a:solidFill>
+                        <a:srgbClr val="D9E2EC"/>
+                      </a:solidFill>
+                      <a:prstDash val="solid"/>
+                      <a:round/>
+                      <a:headEnd type="none" w="med" len="med"/>
+                      <a:tailEnd type="none" w="med" len="med"/>
+                    </a:lnT>
+                    <a:lnB w="6350" cap="flat" cmpd="sng" algn="ctr">
+                      <a:solidFill>
+                        <a:srgbClr val="D9E2EC"/>
+                      </a:solidFill>
+                      <a:prstDash val="solid"/>
+                      <a:round/>
+                      <a:headEnd type="none" w="med" len="med"/>
+                      <a:tailEnd type="none" w="med" len="med"/>
+                    </a:lnB>
+                  </a:tcPr>
+                </a:tc>
+                <a:tc>
+                  <a:txBody>
+                    <a:bodyPr/>
+                    <a:lstStyle/>
+                    <a:p>
+                      <a:pPr algn="l" indent="0" marL="0">
+                        <a:buNone/>
+                      </a:pPr>
+                      <a:r>
+                        <a:rPr lang="en-US" sz="1100" dirty="0">
+                          <a:solidFill>
+                            <a:srgbClr val="70819A"/>
+                          </a:solidFill>
+                        </a:rPr>
+                        <a:t>recall ↓, no gain</a:t>
+                      </a:r>
+                      <a:endParaRPr lang="en-US" sz="1100" dirty="0"/>
+                    </a:p>
+                  </a:txBody>
+                  <a:tcPr marL="91440" marR="91440" marT="45720" marB="45720" anchor="ctr">
+                    <a:lnL w="6350" cap="flat" cmpd="sng" algn="ctr">
+                      <a:solidFill>
+                        <a:srgbClr val="D9E2EC"/>
+                      </a:solidFill>
+                      <a:prstDash val="solid"/>
+                      <a:round/>
+                      <a:headEnd type="none" w="med" len="med"/>
+                      <a:tailEnd type="none" w="med" len="med"/>
+                    </a:lnL>
+                    <a:lnR w="6350" cap="flat" cmpd="sng" algn="ctr">
+                      <a:solidFill>
+                        <a:srgbClr val="D9E2EC"/>
+                      </a:solidFill>
+                      <a:prstDash val="solid"/>
+                      <a:round/>
+                      <a:headEnd type="none" w="med" len="med"/>
+                      <a:tailEnd type="none" w="med" len="med"/>
+                    </a:lnR>
+                    <a:lnT w="6350" cap="flat" cmpd="sng" algn="ctr">
+                      <a:solidFill>
+                        <a:srgbClr val="D9E2EC"/>
+                      </a:solidFill>
+                      <a:prstDash val="solid"/>
+                      <a:round/>
+                      <a:headEnd type="none" w="med" len="med"/>
+                      <a:tailEnd type="none" w="med" len="med"/>
+                    </a:lnT>
+                    <a:lnB w="6350" cap="flat" cmpd="sng" algn="ctr">
+                      <a:solidFill>
+                        <a:srgbClr val="D9E2EC"/>
+                      </a:solidFill>
+                      <a:prstDash val="solid"/>
+                      <a:round/>
+                      <a:headEnd type="none" w="med" len="med"/>
+                      <a:tailEnd type="none" w="med" len="med"/>
+                    </a:lnB>
+                  </a:tcPr>
+                </a:tc>
+              </a:tr>
+            </a:tbl>
+          </a:graphicData>
+        </a:graphic>
+      </p:graphicFrame>
+      <p:sp>
+        <p:nvSpPr>
+          <p:cNvPr id="7" name="Shape 4"/>
+          <p:cNvSpPr/>
+          <p:nvPr/>
+        </p:nvSpPr>
+        <p:spPr>
+          <a:xfrm>
+            <a:off x="457200" y="4709160"/>
+            <a:ext cx="11274552" cy="1417320"/>
+          </a:xfrm>
+          <a:prstGeom prst="roundRect">
+            <a:avLst>
+              <a:gd name="adj" fmla="val 5161"/>
+            </a:avLst>
+          </a:prstGeom>
+          <a:solidFill>
+            <a:srgbClr val="FCEDEB"/>
+          </a:solidFill>
+          <a:ln w="12700">
+            <a:solidFill>
+              <a:srgbClr val="D9E2EC"/>
+            </a:solidFill>
+            <a:prstDash val="solid"/>
+          </a:ln>
+          <a:effectLst>
+            <a:outerShdw sx="100000" sy="100000" kx="0" ky="0" algn="bl" rotWithShape="0" blurRad="101600" dist="38100" dir="5400000">
+              <a:srgbClr val="8AA0B5">
+                <a:alpha val="25000"/>
+              </a:srgbClr>
+            </a:outerShdw>
+          </a:effectLst>
+        </p:spPr>
+      </p:sp>
+      <p:sp>
+        <p:nvSpPr>
+          <p:cNvPr id="8" name="Text 5"/>
+          <p:cNvSpPr/>
+          <p:nvPr/>
+        </p:nvSpPr>
+        <p:spPr>
+          <a:xfrm>
+            <a:off x="685800" y="4846320"/>
+            <a:ext cx="10817352" cy="365760"/>
+          </a:xfrm>
+          <a:prstGeom prst="rect">
+            <a:avLst/>
+          </a:prstGeom>
+          <a:noFill/>
+          <a:ln/>
+        </p:spPr>
+        <p:txBody>
+          <a:bodyPr wrap="square" lIns="0" tIns="0" rIns="0" bIns="0" rtlCol="0" anchor="ctr"/>
+          <a:lstStyle/>
+          <a:p>
+            <a:pPr indent="0" marL="0">
+              <a:buNone/>
+            </a:pPr>
+            <a:r>
+              <a:rPr lang="en-US" sz="1500" b="1" dirty="0">
+                <a:solidFill>
+                  <a:srgbClr val="C0392B"/>
+                </a:solidFill>
+              </a:rPr>
+              <a:t>One ceiling, confirmed three ways</a:t>
+            </a:r>
+            <a:endParaRPr lang="en-US" sz="1500" dirty="0"/>
+          </a:p>
+        </p:txBody>
+      </p:sp>
+      <p:sp>
+        <p:nvSpPr>
+          <p:cNvPr id="9" name="Text 6"/>
+          <p:cNvSpPr/>
+          <p:nvPr/>
+        </p:nvSpPr>
+        <p:spPr>
+          <a:xfrm>
+            <a:off x="685800" y="5212080"/>
+            <a:ext cx="10817352" cy="868680"/>
+          </a:xfrm>
+          <a:prstGeom prst="rect">
+            <a:avLst/>
+          </a:prstGeom>
+          <a:noFill/>
+          <a:ln/>
+        </p:spPr>
+        <p:txBody>
+          <a:bodyPr wrap="square" lIns="0" tIns="0" rIns="0" bIns="0" rtlCol="0" anchor="t"/>
+          <a:lstStyle/>
+          <a:p>
+            <a:pPr indent="0" marL="0">
+              <a:buNone/>
+            </a:pPr>
+            <a:r>
+              <a:rPr lang="en-US" sz="1300" dirty="0">
+                <a:solidFill>
+                  <a:srgbClr val="33475B"/>
+                </a:solidFill>
+              </a:rPr>
+              <a:t>Every approach lands in the same 0.82–0.84 accuracy / ~0.90 AUC band. Where a single test split looked better (feature engineering, 0.837), 5-fold cross-validation did NOT confirm it — the tell-tale sign of noise, not signal. We kept Gradient Boosting for its best held-out recall and AUC, the metrics that matter for triage.</a:t>
+            </a:r>
+            <a:endParaRPr lang="en-US" sz="1300" dirty="0"/>
+          </a:p>
+        </p:txBody>
+      </p:sp>
+      <p:sp>
+        <p:nvSpPr>
+          <p:cNvPr id="10" name="Text 7"/>
+          <p:cNvSpPr/>
+          <p:nvPr/>
+        </p:nvSpPr>
+        <p:spPr>
+          <a:xfrm>
+            <a:off x="457200" y="6473952"/>
+            <a:ext cx="7315200" cy="274320"/>
+          </a:xfrm>
+          <a:prstGeom prst="rect">
+            <a:avLst/>
+          </a:prstGeom>
+          <a:noFill/>
+          <a:ln/>
+        </p:spPr>
+        <p:txBody>
+          <a:bodyPr wrap="square" lIns="0" tIns="0" rIns="0" bIns="0" rtlCol="0" anchor="ctr"/>
+          <a:lstStyle/>
+          <a:p>
+            <a:pPr indent="0" marL="0">
+              <a:buNone/>
+            </a:pPr>
+            <a:r>
+              <a:rPr lang="en-US" sz="900" dirty="0">
+                <a:solidFill>
+                  <a:srgbClr val="70819A"/>
+                </a:solidFill>
+              </a:rPr>
+              <a:t>CardioTriage AI  ·  Machine Learning Phase</a:t>
+            </a:r>
+            <a:endParaRPr lang="en-US" sz="900" dirty="0"/>
+          </a:p>
+        </p:txBody>
+      </p:sp>
+      <p:sp>
+        <p:nvSpPr>
+          <p:cNvPr id="11" name="Text 8"/>
+          <p:cNvSpPr/>
+          <p:nvPr/>
+        </p:nvSpPr>
+        <p:spPr>
+          <a:xfrm>
+            <a:off x="11274552" y="6473952"/>
+            <a:ext cx="457200" cy="274320"/>
+          </a:xfrm>
+          <a:prstGeom prst="rect">
+            <a:avLst/>
+          </a:prstGeom>
+          <a:noFill/>
+          <a:ln/>
+        </p:spPr>
+        <p:txBody>
+          <a:bodyPr wrap="square" lIns="0" tIns="0" rIns="0" bIns="0" rtlCol="0" anchor="ctr"/>
+          <a:lstStyle/>
+          <a:p>
+            <a:pPr algn="r" indent="0" marL="0">
+              <a:buNone/>
+            </a:pPr>
+            <a:r>
+              <a:rPr lang="en-US" sz="900" dirty="0">
+                <a:solidFill>
+                  <a:srgbClr val="70819A"/>
+                </a:solidFill>
+              </a:rPr>
+              <a:t>17</a:t>
+            </a:r>
+            <a:endParaRPr lang="en-US" sz="900" dirty="0"/>
+          </a:p>
+        </p:txBody>
+      </p:sp>
+    </p:spTree>
+  </p:cSld>
+  <p:clrMapOvr>
+    <a:masterClrMapping/>
+  </p:clrMapOvr>
+</p:sld>
+</file>
+
+<file path=ppt/slides/slide18.xml><?xml version="1.0" encoding="utf-8"?>
+<p:sld xmlns:a="http://schemas.openxmlformats.org/drawingml/2006/main" xmlns:r="http://schemas.openxmlformats.org/officeDocument/2006/relationships" xmlns:p="http://schemas.openxmlformats.org/presentationml/2006/main">
+  <p:cSld name="Slide 18">
+    <p:bg>
+      <p:bgPr>
+        <a:solidFill>
+          <a:srgbClr val="FFFFFF"/>
+        </a:solidFill>
+      </p:bgPr>
+    </p:bg>
+    <p:spTree>
+      <p:nvGrpSpPr>
+        <p:cNvPr id="1" name=""/>
+        <p:cNvGrpSpPr/>
+        <p:nvPr/>
+      </p:nvGrpSpPr>
+      <p:grpSpPr>
+        <a:xfrm>
+          <a:off x="0" y="0"/>
+          <a:ext cx="0" cy="0"/>
+          <a:chOff x="0" y="0"/>
+          <a:chExt cx="0" cy="0"/>
+        </a:xfrm>
+      </p:grpSpPr>
+      <p:sp>
+        <p:nvSpPr>
+          <p:cNvPr id="2" name="Shape 0"/>
+          <p:cNvSpPr/>
+          <p:nvPr/>
+        </p:nvSpPr>
+        <p:spPr>
+          <a:xfrm>
+            <a:off x="457200" y="384048"/>
+            <a:ext cx="1417320" cy="384048"/>
+          </a:xfrm>
+          <a:prstGeom prst="roundRect">
+            <a:avLst>
+              <a:gd name="adj" fmla="val 19048"/>
+            </a:avLst>
+          </a:prstGeom>
+          <a:solidFill>
+            <a:srgbClr val="C0392B"/>
+          </a:solidFill>
+          <a:ln/>
+        </p:spPr>
+      </p:sp>
+      <p:sp>
+        <p:nvSpPr>
+          <p:cNvPr id="3" name="Text 1"/>
+          <p:cNvSpPr/>
+          <p:nvPr/>
+        </p:nvSpPr>
+        <p:spPr>
+          <a:xfrm>
+            <a:off x="457200" y="384048"/>
+            <a:ext cx="1417320" cy="384048"/>
+          </a:xfrm>
+          <a:prstGeom prst="rect">
+            <a:avLst/>
+          </a:prstGeom>
+          <a:noFill/>
+          <a:ln/>
+        </p:spPr>
+        <p:txBody>
+          <a:bodyPr wrap="square" lIns="0" tIns="0" rIns="0" bIns="0" rtlCol="0" anchor="ctr"/>
+          <a:lstStyle/>
+          <a:p>
+            <a:pPr algn="ctr" indent="0" marL="0">
+              <a:buNone/>
+            </a:pPr>
+            <a:r>
+              <a:rPr lang="en-US" sz="1300" b="1" dirty="0">
+                <a:solidFill>
+                  <a:srgbClr val="FFFFFF"/>
+                </a:solidFill>
+                <a:latin typeface="Consolas" pitchFamily="34" charset="0"/>
+                <a:ea typeface="Consolas" pitchFamily="34" charset="-122"/>
+                <a:cs typeface="Consolas" pitchFamily="34" charset="-120"/>
+              </a:rPr>
+              <a:t>EDGE</a:t>
+            </a:r>
+            <a:endParaRPr lang="en-US" sz="1300" dirty="0"/>
+          </a:p>
+        </p:txBody>
+      </p:sp>
+      <p:sp>
+        <p:nvSpPr>
+          <p:cNvPr id="4" name="Text 2"/>
+          <p:cNvSpPr/>
+          <p:nvPr/>
+        </p:nvSpPr>
+        <p:spPr>
+          <a:xfrm>
+            <a:off x="457200" y="868680"/>
+            <a:ext cx="11274552" cy="566928"/>
+          </a:xfrm>
+          <a:prstGeom prst="rect">
+            <a:avLst/>
+          </a:prstGeom>
+          <a:noFill/>
+          <a:ln/>
+        </p:spPr>
+        <p:txBody>
+          <a:bodyPr wrap="square" lIns="0" tIns="0" rIns="0" bIns="0" rtlCol="0" anchor="ctr"/>
+          <a:lstStyle/>
+          <a:p>
+            <a:pPr indent="0" marL="0">
+              <a:buNone/>
+            </a:pPr>
+            <a:r>
+              <a:rPr lang="en-US" sz="2800" b="1" dirty="0">
+                <a:solidFill>
+                  <a:srgbClr val="0F2C3F"/>
+                </a:solidFill>
+                <a:latin typeface="Georgia" pitchFamily="34" charset="0"/>
+                <a:ea typeface="Georgia" pitchFamily="34" charset="-122"/>
+                <a:cs typeface="Georgia" pitchFamily="34" charset="-120"/>
+              </a:rPr>
+              <a:t>Why This Project Has a Clear Edge</a:t>
+            </a:r>
+            <a:endParaRPr lang="en-US" sz="2800" dirty="0"/>
+          </a:p>
+        </p:txBody>
+      </p:sp>
+      <p:sp>
+        <p:nvSpPr>
+          <p:cNvPr id="5" name="Shape 3"/>
+          <p:cNvSpPr/>
+          <p:nvPr/>
+        </p:nvSpPr>
+        <p:spPr>
+          <a:xfrm>
+            <a:off x="457200" y="1783080"/>
+            <a:ext cx="5486400" cy="4480560"/>
+          </a:xfrm>
+          <a:prstGeom prst="roundRect">
+            <a:avLst>
+              <a:gd name="adj" fmla="val 1633"/>
+            </a:avLst>
+          </a:prstGeom>
+          <a:solidFill>
+            <a:srgbClr val="FFFFFF"/>
+          </a:solidFill>
+          <a:ln w="12700">
+            <a:solidFill>
+              <a:srgbClr val="D9E2EC"/>
+            </a:solidFill>
+            <a:prstDash val="solid"/>
+          </a:ln>
+          <a:effectLst>
+            <a:outerShdw sx="100000" sy="100000" kx="0" ky="0" algn="bl" rotWithShape="0" blurRad="101600" dist="38100" dir="5400000">
+              <a:srgbClr val="8AA0B5">
+                <a:alpha val="25000"/>
+              </a:srgbClr>
+            </a:outerShdw>
+          </a:effectLst>
+        </p:spPr>
+      </p:sp>
+      <p:sp>
+        <p:nvSpPr>
+          <p:cNvPr id="6" name="Text 4"/>
+          <p:cNvSpPr/>
+          <p:nvPr/>
+        </p:nvSpPr>
+        <p:spPr>
+          <a:xfrm>
+            <a:off x="640080" y="1901952"/>
+            <a:ext cx="5120640" cy="457200"/>
+          </a:xfrm>
+          <a:prstGeom prst="rect">
+            <a:avLst/>
+          </a:prstGeom>
+          <a:noFill/>
+          <a:ln/>
+        </p:spPr>
+        <p:txBody>
+          <a:bodyPr wrap="square" lIns="0" tIns="0" rIns="0" bIns="0" rtlCol="0" anchor="ctr"/>
+          <a:lstStyle/>
+          <a:p>
+            <a:pPr indent="0" marL="0">
+              <a:buNone/>
+            </a:pPr>
+            <a:r>
+              <a:rPr lang="en-US" sz="1300" b="1" dirty="0">
+                <a:solidFill>
+                  <a:srgbClr val="0F2C3F"/>
+                </a:solidFill>
+              </a:rPr>
+              <a:t>Cross-validated AUC is flat across every method</a:t>
+            </a:r>
+            <a:endParaRPr lang="en-US" sz="1300" dirty="0"/>
+          </a:p>
+        </p:txBody>
+      </p:sp>
+      <p:graphicFrame>
+        <p:nvGraphicFramePr>
+          <p:cNvPr id="7" name="Chart 0" descr=""/>
+          <p:cNvGraphicFramePr/>
+          <p:nvPr/>
+        </p:nvGraphicFramePr>
+        <p:xfrm>
+          <a:off x="548640" y="2423160"/>
+          <a:ext cx="5303520" cy="3611880"/>
+        </p:xfrm>
+        <a:graphic xmlns:a="http://schemas.openxmlformats.org/drawingml/2006/main">
+          <a:graphicData uri="http://schemas.openxmlformats.org/drawingml/2006/chart">
+            <c:chart xmlns:c="http://schemas.openxmlformats.org/drawingml/2006/chart" r:id="rId1"/>
+          </a:graphicData>
+        </a:graphic>
+      </p:graphicFrame>
+      <p:sp>
+        <p:nvSpPr>
+          <p:cNvPr id="8" name="Text 5"/>
+          <p:cNvSpPr/>
+          <p:nvPr/>
+        </p:nvSpPr>
+        <p:spPr>
+          <a:xfrm>
+            <a:off x="6263640" y="1828800"/>
+            <a:ext cx="5486400" cy="411480"/>
+          </a:xfrm>
+          <a:prstGeom prst="rect">
+            <a:avLst/>
+          </a:prstGeom>
+          <a:noFill/>
+          <a:ln/>
+        </p:spPr>
+        <p:txBody>
+          <a:bodyPr wrap="square" lIns="0" tIns="0" rIns="0" bIns="0" rtlCol="0" anchor="ctr"/>
+          <a:lstStyle/>
+          <a:p>
+            <a:pPr indent="0" marL="0">
+              <a:buNone/>
+            </a:pPr>
+            <a:r>
+              <a:rPr lang="en-US" sz="1600" b="1" dirty="0">
+                <a:solidFill>
+                  <a:srgbClr val="0F2C3F"/>
+                </a:solidFill>
+              </a:rPr>
+              <a:t>What sets this work apart</a:t>
+            </a:r>
+            <a:endParaRPr lang="en-US" sz="1600" dirty="0"/>
+          </a:p>
+        </p:txBody>
+      </p:sp>
+      <p:sp>
+        <p:nvSpPr>
+          <p:cNvPr id="9" name="Text 6"/>
+          <p:cNvSpPr/>
+          <p:nvPr/>
+        </p:nvSpPr>
+        <p:spPr>
+          <a:xfrm>
+            <a:off x="6263640" y="2331720"/>
+            <a:ext cx="5440680" cy="2834640"/>
+          </a:xfrm>
+          <a:prstGeom prst="rect">
+            <a:avLst/>
+          </a:prstGeom>
+          <a:noFill/>
+          <a:ln/>
+        </p:spPr>
+        <p:txBody>
+          <a:bodyPr wrap="square" lIns="0" tIns="0" rIns="0" bIns="0" rtlCol="0" anchor="t"/>
+          <a:lstStyle/>
+          <a:p>
+            <a:pPr marL="177800" indent="-177800">
+              <a:spcAft>
+                <a:spcPts val="600"/>
+              </a:spcAft>
+              <a:buSzPct val="100000"/>
+              <a:buChar char="•"/>
+            </a:pPr>
+            <a:r>
+              <a:rPr lang="en-US" sz="1300" dirty="0">
+                <a:solidFill>
+                  <a:srgbClr val="33475B"/>
+                </a:solidFill>
+              </a:rPr>
+              <a:t>Benchmarked 6 approaches — 3 model families + tuning + engineered features + a neural net. Most projects stop at one.</a:t>
+            </a:r>
+            <a:endParaRPr lang="en-US" sz="1300" dirty="0"/>
+          </a:p>
+          <a:p>
+            <a:pPr marL="177800" indent="-177800">
+              <a:spcAft>
+                <a:spcPts val="600"/>
+              </a:spcAft>
+              <a:buSzPct val="100000"/>
+              <a:buChar char="•"/>
+            </a:pPr>
+            <a:r>
+              <a:rPr lang="en-US" sz="1300" dirty="0">
+                <a:solidFill>
+                  <a:srgbClr val="33475B"/>
+                </a:solidFill>
+              </a:rPr>
+              <a:t>Used cross-validation to reject test-set noise — refused to chase a fragile 0.837 accuracy.</a:t>
+            </a:r>
+            <a:endParaRPr lang="en-US" sz="1300" dirty="0"/>
+          </a:p>
+          <a:p>
+            <a:pPr marL="177800" indent="-177800">
+              <a:spcAft>
+                <a:spcPts val="600"/>
+              </a:spcAft>
+              <a:buSzPct val="100000"/>
+              <a:buChar char="•"/>
+            </a:pPr>
+            <a:r>
+              <a:rPr lang="en-US" sz="1300" dirty="0">
+                <a:solidFill>
+                  <a:srgbClr val="33475B"/>
+                </a:solidFill>
+              </a:rPr>
+              <a:t>Proved the data's ceiling with evidence, not assumption.</a:t>
+            </a:r>
+            <a:endParaRPr lang="en-US" sz="1300" dirty="0"/>
+          </a:p>
+          <a:p>
+            <a:pPr marL="177800" indent="-177800">
+              <a:spcAft>
+                <a:spcPts val="600"/>
+              </a:spcAft>
+              <a:buSzPct val="100000"/>
+              <a:buChar char="•"/>
+            </a:pPr>
+            <a:r>
+              <a:rPr lang="en-US" sz="1300" dirty="0">
+                <a:solidFill>
+                  <a:srgbClr val="33475B"/>
+                </a:solidFill>
+              </a:rPr>
+              <a:t>Optimized recall (clinical safety) over vanity accuracy.</a:t>
+            </a:r>
+            <a:endParaRPr lang="en-US" sz="1300" dirty="0"/>
+          </a:p>
+          <a:p>
+            <a:pPr marL="177800" indent="-177800">
+              <a:spcAft>
+                <a:spcPts val="600"/>
+              </a:spcAft>
+              <a:buSzPct val="100000"/>
+              <a:buChar char="•"/>
+            </a:pPr>
+            <a:r>
+              <a:rPr lang="en-US" sz="1300" dirty="0">
+                <a:solidFill>
+                  <a:srgbClr val="33475B"/>
+                </a:solidFill>
+              </a:rPr>
+              <a:t>Leakage-safe pipeline end-to-end; fully reproducible.</a:t>
+            </a:r>
+            <a:endParaRPr lang="en-US" sz="1300" dirty="0"/>
+          </a:p>
+        </p:txBody>
+      </p:sp>
+      <p:sp>
+        <p:nvSpPr>
+          <p:cNvPr id="10" name="Shape 7"/>
+          <p:cNvSpPr/>
+          <p:nvPr/>
+        </p:nvSpPr>
+        <p:spPr>
+          <a:xfrm>
+            <a:off x="6263640" y="5257800"/>
+            <a:ext cx="5440680" cy="960120"/>
+          </a:xfrm>
+          <a:prstGeom prst="roundRect">
+            <a:avLst>
+              <a:gd name="adj" fmla="val 7619"/>
+            </a:avLst>
+          </a:prstGeom>
+          <a:solidFill>
+            <a:srgbClr val="0F2C3F"/>
+          </a:solidFill>
+          <a:ln w="12700">
+            <a:solidFill>
+              <a:srgbClr val="D9E2EC"/>
+            </a:solidFill>
+            <a:prstDash val="solid"/>
+          </a:ln>
+          <a:effectLst>
+            <a:outerShdw sx="100000" sy="100000" kx="0" ky="0" algn="bl" rotWithShape="0" blurRad="101600" dist="38100" dir="5400000">
+              <a:srgbClr val="8AA0B5">
+                <a:alpha val="25000"/>
+              </a:srgbClr>
+            </a:outerShdw>
+          </a:effectLst>
+        </p:spPr>
+      </p:sp>
+      <p:sp>
+        <p:nvSpPr>
+          <p:cNvPr id="11" name="Text 8"/>
+          <p:cNvSpPr/>
+          <p:nvPr/>
+        </p:nvSpPr>
+        <p:spPr>
+          <a:xfrm>
+            <a:off x="6446520" y="5376672"/>
+            <a:ext cx="5120640" cy="777240"/>
+          </a:xfrm>
+          <a:prstGeom prst="rect">
+            <a:avLst/>
+          </a:prstGeom>
+          <a:noFill/>
+          <a:ln/>
+        </p:spPr>
+        <p:txBody>
+          <a:bodyPr wrap="square" lIns="0" tIns="0" rIns="0" bIns="0" rtlCol="0" anchor="ctr"/>
+          <a:lstStyle/>
+          <a:p>
+            <a:pPr indent="0" marL="0">
+              <a:buNone/>
+            </a:pPr>
+            <a:r>
+              <a:rPr lang="en-US" sz="1300" b="1" i="1" dirty="0">
+                <a:solidFill>
+                  <a:srgbClr val="CADCFC"/>
+                </a:solidFill>
+              </a:rPr>
+              <a:t>Examiners reward understanding WHY, not just HOW — this project shows both.</a:t>
+            </a:r>
+            <a:endParaRPr lang="en-US" sz="1300" dirty="0"/>
+          </a:p>
+        </p:txBody>
+      </p:sp>
+      <p:sp>
+        <p:nvSpPr>
+          <p:cNvPr id="12" name="Text 9"/>
+          <p:cNvSpPr/>
+          <p:nvPr/>
+        </p:nvSpPr>
+        <p:spPr>
+          <a:xfrm>
+            <a:off x="457200" y="6473952"/>
+            <a:ext cx="7315200" cy="274320"/>
+          </a:xfrm>
+          <a:prstGeom prst="rect">
+            <a:avLst/>
+          </a:prstGeom>
+          <a:noFill/>
+          <a:ln/>
+        </p:spPr>
+        <p:txBody>
+          <a:bodyPr wrap="square" lIns="0" tIns="0" rIns="0" bIns="0" rtlCol="0" anchor="ctr"/>
+          <a:lstStyle/>
+          <a:p>
+            <a:pPr indent="0" marL="0">
+              <a:buNone/>
+            </a:pPr>
+            <a:r>
+              <a:rPr lang="en-US" sz="900" dirty="0">
+                <a:solidFill>
+                  <a:srgbClr val="70819A"/>
+                </a:solidFill>
+              </a:rPr>
+              <a:t>CardioTriage AI  ·  Machine Learning Phase</a:t>
+            </a:r>
+            <a:endParaRPr lang="en-US" sz="900" dirty="0"/>
+          </a:p>
+        </p:txBody>
+      </p:sp>
+      <p:sp>
+        <p:nvSpPr>
+          <p:cNvPr id="13" name="Text 10"/>
+          <p:cNvSpPr/>
+          <p:nvPr/>
+        </p:nvSpPr>
+        <p:spPr>
+          <a:xfrm>
+            <a:off x="11274552" y="6473952"/>
+            <a:ext cx="457200" cy="274320"/>
+          </a:xfrm>
+          <a:prstGeom prst="rect">
+            <a:avLst/>
+          </a:prstGeom>
+          <a:noFill/>
+          <a:ln/>
+        </p:spPr>
+        <p:txBody>
+          <a:bodyPr wrap="square" lIns="0" tIns="0" rIns="0" bIns="0" rtlCol="0" anchor="ctr"/>
+          <a:lstStyle/>
+          <a:p>
+            <a:pPr algn="r" indent="0" marL="0">
+              <a:buNone/>
+            </a:pPr>
+            <a:r>
+              <a:rPr lang="en-US" sz="900" dirty="0">
+                <a:solidFill>
+                  <a:srgbClr val="70819A"/>
+                </a:solidFill>
+              </a:rPr>
+              <a:t>18</a:t>
+            </a:r>
+            <a:endParaRPr lang="en-US" sz="900" dirty="0"/>
+          </a:p>
+        </p:txBody>
+      </p:sp>
+    </p:spTree>
+  </p:cSld>
+  <p:clrMapOvr>
+    <a:masterClrMapping/>
+  </p:clrMapOvr>
+</p:sld>
+</file>
+
+<file path=ppt/slides/slide19.xml><?xml version="1.0" encoding="utf-8"?>
+<p:sld xmlns:a="http://schemas.openxmlformats.org/drawingml/2006/main" xmlns:r="http://schemas.openxmlformats.org/officeDocument/2006/relationships" xmlns:p="http://schemas.openxmlformats.org/presentationml/2006/main">
+  <p:cSld name="Slide 19">
+    <p:bg>
+      <p:bgPr>
+        <a:solidFill>
           <a:srgbClr val="EEF3F8"/>
         </a:solidFill>
       </p:bgPr>

</xml_diff>